<commit_message>
Add fully on-premise (no SAP BTP) architecture diagram
New SVG and two slides in the architecture deck showing the proxy with
any OIDC provider and SAP systems trusting it via SAML bearer, without
any BTP services.

Co-Authored-By: Claude Opus 5.5 <noreply@anthropic.com>
Claude-Session: https://claude.ai/code/session_0148J4y5wPKquJ9WhLGCJ92J
</commit_message>
<xml_diff>
--- a/docs/architecture/odata-mcp-proxy-architecture.pptx
+++ b/docs/architecture/odata-mcp-proxy-architecture.pptx
@@ -9,9 +9,11 @@
     <p:sldId id="257" r:id="rId3"/>
     <p:sldId id="258" r:id="rId4"/>
     <p:sldId id="259" r:id="rId5"/>
+    <p:sldId id="260" r:id="rId6"/>
+    <p:sldId id="261" r:id="rId7"/>
   </p:sldIdLst>
   <p:notesMasterIdLst>
-    <p:notesMasterId r:id="rId6"/>
+    <p:notesMasterId r:id="rId8"/>
   </p:notesMasterIdLst>
   <p:sldSz cx="12192000" cy="6858000"/>
   <p:notesSz cx="6858000" cy="12192000"/>
@@ -802,6 +804,186 @@
             <a:fld id="{F7021451-1387-4CA6-816F-3879F97B5CBC}" type="slidenum">
               <a:rPr lang="en-US"/>
               <a:t>4</a:t>
+            </a:fld>
+            <a:endParaRPr lang="en-US"/>
+          </a:p>
+        </p:txBody>
+      </p:sp>
+    </p:spTree>
+    <p:extLst>
+      <p:ext uri="{BB962C8B-B14F-4D97-AF65-F5344CB8AC3E}">
+        <p14:creationId xmlns:p14="http://schemas.microsoft.com/office/powerpoint/2010/main" val="1024086991"/>
+      </p:ext>
+    </p:extLst>
+  </p:cSld>
+  <p:clrMapOvr>
+    <a:masterClrMapping/>
+  </p:clrMapOvr>
+</p:notes>
+</file>
+
+<file path=ppt/notesSlides/notesSlide5.xml><?xml version="1.0" encoding="utf-8"?>
+<p:notes xmlns:a="http://schemas.openxmlformats.org/drawingml/2006/main" xmlns:r="http://schemas.openxmlformats.org/officeDocument/2006/relationships" xmlns:p="http://schemas.openxmlformats.org/presentationml/2006/main">
+  <p:cSld>
+    <p:spTree>
+      <p:nvGrpSpPr>
+        <p:cNvPr id="1" name=""/>
+        <p:cNvGrpSpPr/>
+        <p:nvPr/>
+      </p:nvGrpSpPr>
+      <p:grpSpPr>
+        <a:xfrm>
+          <a:off x="0" y="0"/>
+          <a:ext cx="0" cy="0"/>
+          <a:chOff x="0" y="0"/>
+          <a:chExt cx="0" cy="0"/>
+        </a:xfrm>
+      </p:grpSpPr>
+      <p:sp>
+        <p:nvSpPr>
+          <p:cNvPr id="2" name="Slide Image Placeholder 1"/>
+          <p:cNvSpPr>
+            <a:spLocks noGrp="1" noRot="1" noChangeAspect="1"/>
+          </p:cNvSpPr>
+          <p:nvPr>
+            <p:ph type="sldImg"/>
+          </p:nvPr>
+        </p:nvSpPr>
+        <p:spPr/>
+      </p:sp>
+      <p:sp>
+        <p:nvSpPr>
+          <p:cNvPr id="3" name="Notes Placeholder 2"/>
+          <p:cNvSpPr>
+            <a:spLocks noGrp="1"/>
+          </p:cNvSpPr>
+          <p:nvPr>
+            <p:ph type="body" idx="1"/>
+          </p:nvPr>
+        </p:nvSpPr>
+        <p:spPr/>
+        <p:txBody>
+          <a:bodyPr/>
+          <a:lstStyle/>
+          <a:p>
+            <a:r>
+              <a:rPr lang="en-US" dirty="0"/>
+              <a:t>Fully on-premise: no SAP BTP subaccount, Destination service, Connectivity, Cloud Connector or XSUAA. Each SAP system trusts the proxy as SAML bearer assertion issuer.</a:t>
+            </a:r>
+            <a:endParaRPr lang="en-US" dirty="0"/>
+          </a:p>
+        </p:txBody>
+      </p:sp>
+      <p:sp>
+        <p:nvSpPr>
+          <p:cNvPr id="4" name="Slide Number Placeholder 3"/>
+          <p:cNvSpPr>
+            <a:spLocks noGrp="1"/>
+          </p:cNvSpPr>
+          <p:nvPr>
+            <p:ph type="sldNum" sz="quarter" idx="10"/>
+          </p:nvPr>
+        </p:nvSpPr>
+        <p:spPr/>
+        <p:txBody>
+          <a:bodyPr/>
+          <a:lstStyle/>
+          <a:p>
+            <a:fld id="{F7021451-1387-4CA6-816F-3879F97B5CBC}" type="slidenum">
+              <a:rPr lang="en-US"/>
+              <a:t>5</a:t>
+            </a:fld>
+            <a:endParaRPr lang="en-US"/>
+          </a:p>
+        </p:txBody>
+      </p:sp>
+    </p:spTree>
+    <p:extLst>
+      <p:ext uri="{BB962C8B-B14F-4D97-AF65-F5344CB8AC3E}">
+        <p14:creationId xmlns:p14="http://schemas.microsoft.com/office/powerpoint/2010/main" val="1024086991"/>
+      </p:ext>
+    </p:extLst>
+  </p:cSld>
+  <p:clrMapOvr>
+    <a:masterClrMapping/>
+  </p:clrMapOvr>
+</p:notes>
+</file>
+
+<file path=ppt/notesSlides/notesSlide6.xml><?xml version="1.0" encoding="utf-8"?>
+<p:notes xmlns:a="http://schemas.openxmlformats.org/drawingml/2006/main" xmlns:r="http://schemas.openxmlformats.org/officeDocument/2006/relationships" xmlns:p="http://schemas.openxmlformats.org/presentationml/2006/main">
+  <p:cSld>
+    <p:spTree>
+      <p:nvGrpSpPr>
+        <p:cNvPr id="1" name=""/>
+        <p:cNvGrpSpPr/>
+        <p:nvPr/>
+      </p:nvGrpSpPr>
+      <p:grpSpPr>
+        <a:xfrm>
+          <a:off x="0" y="0"/>
+          <a:ext cx="0" cy="0"/>
+          <a:chOff x="0" y="0"/>
+          <a:chExt cx="0" cy="0"/>
+        </a:xfrm>
+      </p:grpSpPr>
+      <p:sp>
+        <p:nvSpPr>
+          <p:cNvPr id="2" name="Slide Image Placeholder 1"/>
+          <p:cNvSpPr>
+            <a:spLocks noGrp="1" noRot="1" noChangeAspect="1"/>
+          </p:cNvSpPr>
+          <p:nvPr>
+            <p:ph type="sldImg"/>
+          </p:nvPr>
+        </p:nvSpPr>
+        <p:spPr/>
+      </p:sp>
+      <p:sp>
+        <p:nvSpPr>
+          <p:cNvPr id="3" name="Notes Placeholder 2"/>
+          <p:cNvSpPr>
+            <a:spLocks noGrp="1"/>
+          </p:cNvSpPr>
+          <p:nvPr>
+            <p:ph type="body" idx="1"/>
+          </p:nvPr>
+        </p:nvSpPr>
+        <p:spPr/>
+        <p:txBody>
+          <a:bodyPr/>
+          <a:lstStyle/>
+          <a:p>
+            <a:r>
+              <a:rPr lang="en-US" dirty="0"/>
+              <a:t>1. MCP request: Clients reach the Node.js server through a reverse proxy that terminates TLS. /mcp requires a bearer token.
+2. Single sign-on with any OIDC IdP: /oauth/* proxies the login to Entra ID, Okta, Keycloak, SAP IAS, … Tokens are verified against the IdP's JWKS.
+3. SAML bearer to SAP: The proxy signs a SAML assertion for the user with the key from the secret store and exchanges it at SAP's OAuth server.
+4. OData as the business user: The S/4HANA call carries the user's own SAP token, so SAP authorizations apply per user. Tokens are cached per user.
+5. More SAP systems: Every ABAP system is a separate destination with its own trust set-up and AUTH_TYPE (per user or technical user).</a:t>
+            </a:r>
+            <a:endParaRPr lang="en-US" dirty="0"/>
+          </a:p>
+        </p:txBody>
+      </p:sp>
+      <p:sp>
+        <p:nvSpPr>
+          <p:cNvPr id="4" name="Slide Number Placeholder 3"/>
+          <p:cNvSpPr>
+            <a:spLocks noGrp="1"/>
+          </p:cNvSpPr>
+          <p:nvPr>
+            <p:ph type="sldNum" sz="quarter" idx="10"/>
+          </p:nvPr>
+        </p:nvSpPr>
+        <p:spPr/>
+        <p:txBody>
+          <a:bodyPr/>
+          <a:lstStyle/>
+          <a:p>
+            <a:fld id="{F7021451-1387-4CA6-816F-3879F97B5CBC}" type="slidenum">
+              <a:rPr lang="en-US"/>
+              <a:t>6</a:t>
             </a:fld>
             <a:endParaRPr lang="en-US"/>
           </a:p>
@@ -4205,7 +4387,7 @@
       </p:pic>
       <p:pic>
         <p:nvPicPr>
-          <p:cNvPr id="87" name="Image 5" descr="Connectivity service icon">    </p:cNvPr>
+          <p:cNvPr id="87" name="Image 5" descr="SAP Cloud Identity icon">    </p:cNvPr>
           <p:cNvPicPr>
             <a:picLocks noChangeAspect="1"/>
           </p:cNvPicPr>
@@ -4219,7 +4401,7 @@
         </p:blipFill>
         <p:spPr>
           <a:xfrm>
-            <a:off x="5914998" y="2336255"/>
+            <a:off x="3277685" y="4782458"/>
             <a:ext cx="198754" cy="198754"/>
           </a:xfrm>
           <a:prstGeom prst="rect">
@@ -4229,7 +4411,7 @@
       </p:pic>
       <p:pic>
         <p:nvPicPr>
-          <p:cNvPr id="88" name="Image 6" descr="SAP Cloud Identity icon">    </p:cNvPr>
+          <p:cNvPr id="88" name="Image 6" descr="SAP BTP Core Services APIs icon">    </p:cNvPr>
           <p:cNvPicPr>
             <a:picLocks noChangeAspect="1"/>
           </p:cNvPicPr>
@@ -4243,7 +4425,7 @@
         </p:blipFill>
         <p:spPr>
           <a:xfrm>
-            <a:off x="3277685" y="4782458"/>
+            <a:off x="5876776" y="5470453"/>
             <a:ext cx="198754" cy="198754"/>
           </a:xfrm>
           <a:prstGeom prst="rect">
@@ -4253,7 +4435,7 @@
       </p:pic>
       <p:pic>
         <p:nvPicPr>
-          <p:cNvPr id="89" name="Image 7" descr="SAP Integration Suite icon">    </p:cNvPr>
+          <p:cNvPr id="89" name="Image 7" descr="SAP Cloud Connector icon">    </p:cNvPr>
           <p:cNvPicPr>
             <a:picLocks noChangeAspect="1"/>
           </p:cNvPicPr>
@@ -4267,7 +4449,7 @@
         </p:blipFill>
         <p:spPr>
           <a:xfrm>
-            <a:off x="5876776" y="4782458"/>
+            <a:off x="9469636" y="2336255"/>
             <a:ext cx="198754" cy="198754"/>
           </a:xfrm>
           <a:prstGeom prst="rect">
@@ -4277,7 +4459,7 @@
       </p:pic>
       <p:pic>
         <p:nvPicPr>
-          <p:cNvPr id="90" name="Image 8" descr="SAP BTP Core Services APIs icon">    </p:cNvPr>
+          <p:cNvPr id="90" name="Image 8" descr="SAP Integration Suite icon">    </p:cNvPr>
           <p:cNvPicPr>
             <a:picLocks noChangeAspect="1"/>
           </p:cNvPicPr>
@@ -4291,7 +4473,7 @@
         </p:blipFill>
         <p:spPr>
           <a:xfrm>
-            <a:off x="5876776" y="5470453"/>
+            <a:off x="5876776" y="4782458"/>
             <a:ext cx="198754" cy="198754"/>
           </a:xfrm>
           <a:prstGeom prst="rect">
@@ -4301,7 +4483,7 @@
       </p:pic>
       <p:pic>
         <p:nvPicPr>
-          <p:cNvPr id="91" name="Image 9" descr="SAP S/4HANA / ABAP icon">    </p:cNvPr>
+          <p:cNvPr id="91" name="Image 9" descr="Connectivity service icon">    </p:cNvPr>
           <p:cNvPicPr>
             <a:picLocks noChangeAspect="1"/>
           </p:cNvPicPr>
@@ -4315,7 +4497,7 @@
         </p:blipFill>
         <p:spPr>
           <a:xfrm>
-            <a:off x="9469636" y="3559357"/>
+            <a:off x="5914998" y="2336255"/>
             <a:ext cx="198754" cy="198754"/>
           </a:xfrm>
           <a:prstGeom prst="rect">
@@ -4325,7 +4507,7 @@
       </p:pic>
       <p:pic>
         <p:nvPicPr>
-          <p:cNvPr id="92" name="Image 10" descr="SAP Cloud Connector icon">    </p:cNvPr>
+          <p:cNvPr id="92" name="Image 10" descr="SAP S/4HANA / ABAP icon">    </p:cNvPr>
           <p:cNvPicPr>
             <a:picLocks noChangeAspect="1"/>
           </p:cNvPicPr>
@@ -4339,7 +4521,7 @@
         </p:blipFill>
         <p:spPr>
           <a:xfrm>
-            <a:off x="9469636" y="2336255"/>
+            <a:off x="9469636" y="3559357"/>
             <a:ext cx="198754" cy="198754"/>
           </a:xfrm>
           <a:prstGeom prst="rect">
@@ -8039,7 +8221,7 @@
       </p:sp>
       <p:pic>
         <p:nvPicPr>
-          <p:cNvPr id="76" name="Image 0" descr="MCP client icon">    </p:cNvPr>
+          <p:cNvPr id="76" name="Image 0" descr="Reverse proxy icon">    </p:cNvPr>
           <p:cNvPicPr>
             <a:picLocks noChangeAspect="1"/>
           </p:cNvPicPr>
@@ -8053,7 +8235,7 @@
         </p:blipFill>
         <p:spPr>
           <a:xfrm>
-            <a:off x="793260" y="1533595"/>
+            <a:off x="3086575" y="1686483"/>
             <a:ext cx="198754" cy="198754"/>
           </a:xfrm>
           <a:prstGeom prst="rect">
@@ -8063,7 +8245,7 @@
       </p:pic>
       <p:pic>
         <p:nvPicPr>
-          <p:cNvPr id="77" name="Image 1" descr="odata-mcp-proxy icon">    </p:cNvPr>
+          <p:cNvPr id="77" name="Image 1" descr="MCP client icon">    </p:cNvPr>
           <p:cNvPicPr>
             <a:picLocks noChangeAspect="1"/>
           </p:cNvPicPr>
@@ -8077,7 +8259,7 @@
         </p:blipFill>
         <p:spPr>
           <a:xfrm>
-            <a:off x="4997671" y="1571817"/>
+            <a:off x="793260" y="1533595"/>
             <a:ext cx="198754" cy="198754"/>
           </a:xfrm>
           <a:prstGeom prst="rect">
@@ -8087,7 +8269,7 @@
       </p:pic>
       <p:pic>
         <p:nvPicPr>
-          <p:cNvPr id="78" name="Image 2" descr="Reverse proxy icon">    </p:cNvPr>
+          <p:cNvPr id="78" name="Image 2" descr="Any OIDC IdP icon">    </p:cNvPr>
           <p:cNvPicPr>
             <a:picLocks noChangeAspect="1"/>
           </p:cNvPicPr>
@@ -8101,7 +8283,7 @@
         </p:blipFill>
         <p:spPr>
           <a:xfrm>
-            <a:off x="3086575" y="1686483"/>
+            <a:off x="793260" y="4820680"/>
             <a:ext cx="198754" cy="198754"/>
           </a:xfrm>
           <a:prstGeom prst="rect">
@@ -8111,7 +8293,7 @@
       </p:pic>
       <p:pic>
         <p:nvPicPr>
-          <p:cNvPr id="79" name="Image 3" descr="Any OIDC IdP icon">    </p:cNvPr>
+          <p:cNvPr id="79" name="Image 3" descr="odata-mcp-proxy icon">    </p:cNvPr>
           <p:cNvPicPr>
             <a:picLocks noChangeAspect="1"/>
           </p:cNvPicPr>
@@ -8125,7 +8307,7 @@
         </p:blipFill>
         <p:spPr>
           <a:xfrm>
-            <a:off x="793260" y="4820680"/>
+            <a:off x="4997671" y="1571817"/>
             <a:ext cx="198754" cy="198754"/>
           </a:xfrm>
           <a:prstGeom prst="rect">
@@ -8135,7 +8317,7 @@
       </p:pic>
       <p:pic>
         <p:nvPicPr>
-          <p:cNvPr id="80" name="Image 4" descr="Secret store icon">    </p:cNvPr>
+          <p:cNvPr id="80" name="Image 4" descr="XSUAA icon">    </p:cNvPr>
           <p:cNvPicPr>
             <a:picLocks noChangeAspect="1"/>
           </p:cNvPicPr>
@@ -8149,7 +8331,7 @@
         </p:blipFill>
         <p:spPr>
           <a:xfrm>
-            <a:off x="4997671" y="3712245"/>
+            <a:off x="9469636" y="1778215"/>
             <a:ext cx="198754" cy="198754"/>
           </a:xfrm>
           <a:prstGeom prst="rect">
@@ -8159,7 +8341,7 @@
       </p:pic>
       <p:pic>
         <p:nvPicPr>
-          <p:cNvPr id="81" name="Image 5" descr="SAP S/4HANA icon">    </p:cNvPr>
+          <p:cNvPr id="81" name="Image 5" descr="Secret store icon">    </p:cNvPr>
           <p:cNvPicPr>
             <a:picLocks noChangeAspect="1"/>
           </p:cNvPicPr>
@@ -8173,7 +8355,7 @@
         </p:blipFill>
         <p:spPr>
           <a:xfrm>
-            <a:off x="7176321" y="3788688"/>
+            <a:off x="4997671" y="3712245"/>
             <a:ext cx="198754" cy="198754"/>
           </a:xfrm>
           <a:prstGeom prst="rect">
@@ -8183,7 +8365,7 @@
       </p:pic>
       <p:pic>
         <p:nvPicPr>
-          <p:cNvPr id="82" name="Image 6" descr="XSUAA icon">    </p:cNvPr>
+          <p:cNvPr id="82" name="Image 6" descr="SAP S/4HANA icon">    </p:cNvPr>
           <p:cNvPicPr>
             <a:picLocks noChangeAspect="1"/>
           </p:cNvPicPr>
@@ -8197,7 +8379,7 @@
         </p:blipFill>
         <p:spPr>
           <a:xfrm>
-            <a:off x="9469636" y="1778215"/>
+            <a:off x="7176321" y="3788688"/>
             <a:ext cx="198754" cy="198754"/>
           </a:xfrm>
           <a:prstGeom prst="rect">
@@ -9314,6 +9496,3531 @@
                 <a:cs typeface="Arial" pitchFamily="34" charset="-120"/>
               </a:rPr>
               <a:t>per-user destinations never fall back to the technical user, and backend tokens are cached per user, never shared.</a:t>
+            </a:r>
+            <a:endParaRPr lang="en-US" sz="1100" dirty="0"/>
+          </a:p>
+        </p:txBody>
+      </p:sp>
+    </p:spTree>
+  </p:cSld>
+  <p:clrMapOvr>
+    <a:masterClrMapping/>
+  </p:clrMapOvr>
+</p:sld>
+</file>
+
+<file path=ppt/slides/slide5.xml><?xml version="1.0" encoding="utf-8"?>
+<p:sld xmlns:a="http://schemas.openxmlformats.org/drawingml/2006/main" xmlns:r="http://schemas.openxmlformats.org/officeDocument/2006/relationships" xmlns:p="http://schemas.openxmlformats.org/presentationml/2006/main">
+  <p:cSld name="Slide 5">
+    <p:bg>
+      <p:bgPr>
+        <a:solidFill>
+          <a:srgbClr val="FFFFFF"/>
+        </a:solidFill>
+      </p:bgPr>
+    </p:bg>
+    <p:spTree>
+      <p:nvGrpSpPr>
+        <p:cNvPr id="1" name=""/>
+        <p:cNvGrpSpPr/>
+        <p:nvPr/>
+      </p:nvGrpSpPr>
+      <p:grpSpPr>
+        <a:xfrm>
+          <a:off x="0" y="0"/>
+          <a:ext cx="0" cy="0"/>
+          <a:chOff x="0" y="0"/>
+          <a:chExt cx="0" cy="0"/>
+        </a:xfrm>
+      </p:grpSpPr>
+      <p:sp>
+        <p:nvSpPr>
+          <p:cNvPr id="2" name="Text 0"/>
+          <p:cNvSpPr txBox="1"/>
+          <p:nvPr/>
+        </p:nvSpPr>
+        <p:spPr>
+          <a:xfrm>
+            <a:off x="548640" y="274320"/>
+            <a:ext cx="11064240" cy="411480"/>
+          </a:xfrm>
+          <a:prstGeom prst="rect">
+            <a:avLst/>
+          </a:prstGeom>
+          <a:noFill/>
+          <a:ln/>
+        </p:spPr>
+        <p:txBody>
+          <a:bodyPr wrap="square" lIns="0" tIns="0" rIns="0" bIns="0" rtlCol="0" anchor="ctr"/>
+          <a:lstStyle/>
+          <a:p>
+            <a:pPr indent="0" marL="0">
+              <a:buNone/>
+            </a:pPr>
+            <a:r>
+              <a:rPr lang="en-US" sz="2200" b="1" dirty="0">
+                <a:solidFill>
+                  <a:srgbClr val="1D2D3E"/>
+                </a:solidFill>
+                <a:latin typeface="Arial" pitchFamily="34" charset="0"/>
+                <a:ea typeface="Arial" pitchFamily="34" charset="-122"/>
+                <a:cs typeface="Arial" pitchFamily="34" charset="-120"/>
+              </a:rPr>
+              <a:t>OData MCP Proxy — fully on-premise, without SAP BTP</a:t>
+            </a:r>
+            <a:endParaRPr lang="en-US" sz="2200" dirty="0"/>
+          </a:p>
+        </p:txBody>
+      </p:sp>
+      <p:sp>
+        <p:nvSpPr>
+          <p:cNvPr id="3" name="Text 1"/>
+          <p:cNvSpPr txBox="1"/>
+          <p:nvPr/>
+        </p:nvSpPr>
+        <p:spPr>
+          <a:xfrm>
+            <a:off x="548640" y="685800"/>
+            <a:ext cx="11064240" cy="256032"/>
+          </a:xfrm>
+          <a:prstGeom prst="rect">
+            <a:avLst/>
+          </a:prstGeom>
+          <a:noFill/>
+          <a:ln/>
+        </p:spPr>
+        <p:txBody>
+          <a:bodyPr wrap="square" lIns="0" tIns="0" rIns="0" bIns="0" rtlCol="0" anchor="ctr"/>
+          <a:lstStyle/>
+          <a:p>
+            <a:pPr indent="0" marL="0">
+              <a:buNone/>
+            </a:pPr>
+            <a:r>
+              <a:rPr lang="en-US" sz="1100" dirty="0">
+                <a:solidFill>
+                  <a:srgbClr val="556B82"/>
+                </a:solidFill>
+                <a:latin typeface="Arial" pitchFamily="34" charset="0"/>
+                <a:ea typeface="Arial" pitchFamily="34" charset="-122"/>
+                <a:cs typeface="Arial" pitchFamily="34" charset="-120"/>
+              </a:rPr>
+              <a:t>Node.js server, any OpenID Connect provider and SAP systems that trust the proxy directly</a:t>
+            </a:r>
+            <a:endParaRPr lang="en-US" sz="1100" dirty="0"/>
+          </a:p>
+        </p:txBody>
+      </p:sp>
+      <p:sp>
+        <p:nvSpPr>
+          <p:cNvPr id="4" name="Shape 2"/>
+          <p:cNvSpPr/>
+          <p:nvPr/>
+        </p:nvSpPr>
+        <p:spPr>
+          <a:xfrm>
+            <a:off x="548640" y="1067288"/>
+            <a:ext cx="1911096" cy="1758208"/>
+          </a:xfrm>
+          <a:prstGeom prst="roundRect">
+            <a:avLst>
+              <a:gd name="adj" fmla="val 5201"/>
+            </a:avLst>
+          </a:prstGeom>
+          <a:solidFill>
+            <a:srgbClr val="F5F6F7"/>
+          </a:solidFill>
+          <a:ln w="15875">
+            <a:solidFill>
+              <a:srgbClr val="475E75"/>
+            </a:solidFill>
+            <a:prstDash val="solid"/>
+          </a:ln>
+        </p:spPr>
+      </p:sp>
+      <p:sp>
+        <p:nvSpPr>
+          <p:cNvPr id="5" name="Text 3"/>
+          <p:cNvSpPr txBox="1"/>
+          <p:nvPr/>
+        </p:nvSpPr>
+        <p:spPr>
+          <a:xfrm>
+            <a:off x="670950" y="1143732"/>
+            <a:ext cx="1712342" cy="198754"/>
+          </a:xfrm>
+          <a:prstGeom prst="rect">
+            <a:avLst/>
+          </a:prstGeom>
+          <a:noFill/>
+          <a:ln/>
+        </p:spPr>
+        <p:txBody>
+          <a:bodyPr wrap="square" lIns="0" tIns="0" rIns="0" bIns="0" rtlCol="0" anchor="ctr"/>
+          <a:lstStyle/>
+          <a:p>
+            <a:pPr indent="0" marL="0">
+              <a:buNone/>
+            </a:pPr>
+            <a:r>
+              <a:rPr lang="en-US" sz="1050" b="1" dirty="0">
+                <a:solidFill>
+                  <a:srgbClr val="1D2D3E"/>
+                </a:solidFill>
+                <a:latin typeface="Arial" pitchFamily="34" charset="0"/>
+                <a:ea typeface="Arial" pitchFamily="34" charset="-122"/>
+                <a:cs typeface="Arial" pitchFamily="34" charset="-120"/>
+              </a:rPr>
+              <a:t>AI clients</a:t>
+            </a:r>
+            <a:endParaRPr lang="en-US" sz="1050" dirty="0"/>
+          </a:p>
+        </p:txBody>
+      </p:sp>
+      <p:sp>
+        <p:nvSpPr>
+          <p:cNvPr id="6" name="Shape 4"/>
+          <p:cNvSpPr/>
+          <p:nvPr/>
+        </p:nvSpPr>
+        <p:spPr>
+          <a:xfrm>
+            <a:off x="701528" y="1449507"/>
+            <a:ext cx="1605321" cy="1146658"/>
+          </a:xfrm>
+          <a:prstGeom prst="roundRect">
+            <a:avLst>
+              <a:gd name="adj" fmla="val 4785"/>
+            </a:avLst>
+          </a:prstGeom>
+          <a:solidFill>
+            <a:srgbClr val="FFFFFF"/>
+          </a:solidFill>
+          <a:ln w="9525">
+            <a:solidFill>
+              <a:srgbClr val="475E75"/>
+            </a:solidFill>
+            <a:prstDash val="solid"/>
+          </a:ln>
+        </p:spPr>
+      </p:sp>
+      <p:sp>
+        <p:nvSpPr>
+          <p:cNvPr id="7" name="Text 5"/>
+          <p:cNvSpPr txBox="1"/>
+          <p:nvPr/>
+        </p:nvSpPr>
+        <p:spPr>
+          <a:xfrm>
+            <a:off x="1053169" y="1525951"/>
+            <a:ext cx="1192524" cy="214043"/>
+          </a:xfrm>
+          <a:prstGeom prst="rect">
+            <a:avLst/>
+          </a:prstGeom>
+          <a:noFill/>
+          <a:ln/>
+        </p:spPr>
+        <p:txBody>
+          <a:bodyPr wrap="square" lIns="0" tIns="0" rIns="0" bIns="0" rtlCol="0" anchor="ctr"/>
+          <a:lstStyle/>
+          <a:p>
+            <a:pPr indent="0" marL="0">
+              <a:buNone/>
+            </a:pPr>
+            <a:r>
+              <a:rPr lang="en-US" sz="1000" b="1" dirty="0">
+                <a:solidFill>
+                  <a:srgbClr val="1D2D3E"/>
+                </a:solidFill>
+                <a:latin typeface="Arial" pitchFamily="34" charset="0"/>
+                <a:ea typeface="Arial" pitchFamily="34" charset="-122"/>
+                <a:cs typeface="Arial" pitchFamily="34" charset="-120"/>
+              </a:rPr>
+              <a:t>MCP client</a:t>
+            </a:r>
+            <a:endParaRPr lang="en-US" sz="1000" dirty="0"/>
+          </a:p>
+        </p:txBody>
+      </p:sp>
+      <p:sp>
+        <p:nvSpPr>
+          <p:cNvPr id="8" name="Text 6"/>
+          <p:cNvSpPr txBox="1"/>
+          <p:nvPr/>
+        </p:nvSpPr>
+        <p:spPr>
+          <a:xfrm>
+            <a:off x="808549" y="1785860"/>
+            <a:ext cx="1437144" cy="458663"/>
+          </a:xfrm>
+          <a:prstGeom prst="rect">
+            <a:avLst/>
+          </a:prstGeom>
+          <a:noFill/>
+          <a:ln/>
+        </p:spPr>
+        <p:txBody>
+          <a:bodyPr wrap="square" lIns="0" tIns="0" rIns="0" bIns="0" rtlCol="0" anchor="t"/>
+          <a:lstStyle/>
+          <a:p>
+            <a:pPr indent="0" marL="0">
+              <a:lnSpc>
+                <a:spcPct val="105000"/>
+              </a:lnSpc>
+              <a:buNone/>
+            </a:pPr>
+            <a:r>
+              <a:rPr lang="en-US" sz="850" dirty="0">
+                <a:solidFill>
+                  <a:srgbClr val="556B82"/>
+                </a:solidFill>
+                <a:latin typeface="Arial" pitchFamily="34" charset="0"/>
+                <a:ea typeface="Arial" pitchFamily="34" charset="-122"/>
+                <a:cs typeface="Arial" pitchFamily="34" charset="-120"/>
+              </a:rPr>
+              <a:t>Claude, Copilot Studio,</a:t>
+            </a:r>
+            <a:endParaRPr lang="en-US" sz="850" dirty="0"/>
+          </a:p>
+          <a:p>
+            <a:pPr indent="0" marL="0">
+              <a:lnSpc>
+                <a:spcPct val="105000"/>
+              </a:lnSpc>
+              <a:buNone/>
+            </a:pPr>
+            <a:r>
+              <a:rPr lang="en-US" sz="850" dirty="0">
+                <a:solidFill>
+                  <a:srgbClr val="556B82"/>
+                </a:solidFill>
+                <a:latin typeface="Arial" pitchFamily="34" charset="0"/>
+                <a:ea typeface="Arial" pitchFamily="34" charset="-122"/>
+                <a:cs typeface="Arial" pitchFamily="34" charset="-120"/>
+              </a:rPr>
+              <a:t>MCP Inspector, …</a:t>
+            </a:r>
+            <a:endParaRPr lang="en-US" sz="850" dirty="0"/>
+          </a:p>
+          <a:p>
+            <a:pPr indent="0" marL="0">
+              <a:lnSpc>
+                <a:spcPct val="105000"/>
+              </a:lnSpc>
+              <a:buNone/>
+            </a:pPr>
+            <a:r>
+              <a:rPr lang="en-US" sz="850" dirty="0">
+                <a:solidFill>
+                  <a:srgbClr val="556B82"/>
+                </a:solidFill>
+                <a:latin typeface="Arial" pitchFamily="34" charset="0"/>
+                <a:ea typeface="Arial" pitchFamily="34" charset="-122"/>
+                <a:cs typeface="Arial" pitchFamily="34" charset="-120"/>
+              </a:rPr>
+              <a:t>Streamable HTTP + OAuth</a:t>
+            </a:r>
+            <a:endParaRPr lang="en-US" sz="850" dirty="0"/>
+          </a:p>
+        </p:txBody>
+      </p:sp>
+      <p:sp>
+        <p:nvSpPr>
+          <p:cNvPr id="9" name="Shape 7"/>
+          <p:cNvSpPr/>
+          <p:nvPr/>
+        </p:nvSpPr>
+        <p:spPr>
+          <a:xfrm>
+            <a:off x="548640" y="4354373"/>
+            <a:ext cx="1911096" cy="1452433"/>
+          </a:xfrm>
+          <a:prstGeom prst="roundRect">
+            <a:avLst>
+              <a:gd name="adj" fmla="val 6296"/>
+            </a:avLst>
+          </a:prstGeom>
+          <a:solidFill>
+            <a:srgbClr val="F5F6F7"/>
+          </a:solidFill>
+          <a:ln w="15875">
+            <a:solidFill>
+              <a:srgbClr val="475E75"/>
+            </a:solidFill>
+            <a:prstDash val="solid"/>
+          </a:ln>
+        </p:spPr>
+      </p:sp>
+      <p:sp>
+        <p:nvSpPr>
+          <p:cNvPr id="10" name="Text 8"/>
+          <p:cNvSpPr txBox="1"/>
+          <p:nvPr/>
+        </p:nvSpPr>
+        <p:spPr>
+          <a:xfrm>
+            <a:off x="670950" y="4430817"/>
+            <a:ext cx="1712342" cy="198754"/>
+          </a:xfrm>
+          <a:prstGeom prst="rect">
+            <a:avLst/>
+          </a:prstGeom>
+          <a:noFill/>
+          <a:ln/>
+        </p:spPr>
+        <p:txBody>
+          <a:bodyPr wrap="square" lIns="0" tIns="0" rIns="0" bIns="0" rtlCol="0" anchor="ctr"/>
+          <a:lstStyle/>
+          <a:p>
+            <a:pPr indent="0" marL="0">
+              <a:buNone/>
+            </a:pPr>
+            <a:r>
+              <a:rPr lang="en-US" sz="1050" b="1" dirty="0">
+                <a:solidFill>
+                  <a:srgbClr val="1D2D3E"/>
+                </a:solidFill>
+                <a:latin typeface="Arial" pitchFamily="34" charset="0"/>
+                <a:ea typeface="Arial" pitchFamily="34" charset="-122"/>
+                <a:cs typeface="Arial" pitchFamily="34" charset="-120"/>
+              </a:rPr>
+              <a:t>OpenID Connect provider</a:t>
+            </a:r>
+            <a:endParaRPr lang="en-US" sz="1050" dirty="0"/>
+          </a:p>
+        </p:txBody>
+      </p:sp>
+      <p:sp>
+        <p:nvSpPr>
+          <p:cNvPr id="11" name="Shape 9"/>
+          <p:cNvSpPr/>
+          <p:nvPr/>
+        </p:nvSpPr>
+        <p:spPr>
+          <a:xfrm>
+            <a:off x="701528" y="4736592"/>
+            <a:ext cx="1605321" cy="840882"/>
+          </a:xfrm>
+          <a:prstGeom prst="roundRect">
+            <a:avLst>
+              <a:gd name="adj" fmla="val 6525"/>
+            </a:avLst>
+          </a:prstGeom>
+          <a:solidFill>
+            <a:srgbClr val="FFFFFF"/>
+          </a:solidFill>
+          <a:ln w="9525">
+            <a:solidFill>
+              <a:srgbClr val="475E75"/>
+            </a:solidFill>
+            <a:prstDash val="solid"/>
+          </a:ln>
+        </p:spPr>
+      </p:sp>
+      <p:sp>
+        <p:nvSpPr>
+          <p:cNvPr id="12" name="Text 10"/>
+          <p:cNvSpPr txBox="1"/>
+          <p:nvPr/>
+        </p:nvSpPr>
+        <p:spPr>
+          <a:xfrm>
+            <a:off x="1053169" y="4813036"/>
+            <a:ext cx="1192524" cy="214043"/>
+          </a:xfrm>
+          <a:prstGeom prst="rect">
+            <a:avLst/>
+          </a:prstGeom>
+          <a:noFill/>
+          <a:ln/>
+        </p:spPr>
+        <p:txBody>
+          <a:bodyPr wrap="square" lIns="0" tIns="0" rIns="0" bIns="0" rtlCol="0" anchor="ctr"/>
+          <a:lstStyle/>
+          <a:p>
+            <a:pPr indent="0" marL="0">
+              <a:buNone/>
+            </a:pPr>
+            <a:r>
+              <a:rPr lang="en-US" sz="1000" b="1" dirty="0">
+                <a:solidFill>
+                  <a:srgbClr val="1D2D3E"/>
+                </a:solidFill>
+                <a:latin typeface="Arial" pitchFamily="34" charset="0"/>
+                <a:ea typeface="Arial" pitchFamily="34" charset="-122"/>
+                <a:cs typeface="Arial" pitchFamily="34" charset="-120"/>
+              </a:rPr>
+              <a:t>Any OIDC IdP</a:t>
+            </a:r>
+            <a:endParaRPr lang="en-US" sz="1000" dirty="0"/>
+          </a:p>
+        </p:txBody>
+      </p:sp>
+      <p:sp>
+        <p:nvSpPr>
+          <p:cNvPr id="13" name="Text 11"/>
+          <p:cNvSpPr txBox="1"/>
+          <p:nvPr/>
+        </p:nvSpPr>
+        <p:spPr>
+          <a:xfrm>
+            <a:off x="808549" y="5072945"/>
+            <a:ext cx="1437144" cy="321064"/>
+          </a:xfrm>
+          <a:prstGeom prst="rect">
+            <a:avLst/>
+          </a:prstGeom>
+          <a:noFill/>
+          <a:ln/>
+        </p:spPr>
+        <p:txBody>
+          <a:bodyPr wrap="square" lIns="0" tIns="0" rIns="0" bIns="0" rtlCol="0" anchor="t"/>
+          <a:lstStyle/>
+          <a:p>
+            <a:pPr indent="0" marL="0">
+              <a:lnSpc>
+                <a:spcPct val="105000"/>
+              </a:lnSpc>
+              <a:buNone/>
+            </a:pPr>
+            <a:r>
+              <a:rPr lang="en-US" sz="850" dirty="0">
+                <a:solidFill>
+                  <a:srgbClr val="556B82"/>
+                </a:solidFill>
+                <a:latin typeface="Arial" pitchFamily="34" charset="0"/>
+                <a:ea typeface="Arial" pitchFamily="34" charset="-122"/>
+                <a:cs typeface="Arial" pitchFamily="34" charset="-120"/>
+              </a:rPr>
+              <a:t>Entra ID, Okta, Keycloak,</a:t>
+            </a:r>
+            <a:endParaRPr lang="en-US" sz="850" dirty="0"/>
+          </a:p>
+          <a:p>
+            <a:pPr indent="0" marL="0">
+              <a:lnSpc>
+                <a:spcPct val="105000"/>
+              </a:lnSpc>
+              <a:buNone/>
+            </a:pPr>
+            <a:r>
+              <a:rPr lang="en-US" sz="850" dirty="0">
+                <a:solidFill>
+                  <a:srgbClr val="556B82"/>
+                </a:solidFill>
+                <a:latin typeface="Arial" pitchFamily="34" charset="0"/>
+                <a:ea typeface="Arial" pitchFamily="34" charset="-122"/>
+                <a:cs typeface="Arial" pitchFamily="34" charset="-120"/>
+              </a:rPr>
+              <a:t>SAP IAS, Auth0, …</a:t>
+            </a:r>
+            <a:endParaRPr lang="en-US" sz="850" dirty="0"/>
+          </a:p>
+        </p:txBody>
+      </p:sp>
+      <p:sp>
+        <p:nvSpPr>
+          <p:cNvPr id="14" name="Shape 12"/>
+          <p:cNvSpPr/>
+          <p:nvPr/>
+        </p:nvSpPr>
+        <p:spPr>
+          <a:xfrm>
+            <a:off x="2765511" y="914400"/>
+            <a:ext cx="8791042" cy="4968850"/>
+          </a:xfrm>
+          <a:prstGeom prst="roundRect">
+            <a:avLst>
+              <a:gd name="adj" fmla="val 1840"/>
+            </a:avLst>
+          </a:prstGeom>
+          <a:solidFill>
+            <a:srgbClr val="F5F6F7"/>
+          </a:solidFill>
+          <a:ln w="15875">
+            <a:solidFill>
+              <a:srgbClr val="475E75"/>
+            </a:solidFill>
+            <a:prstDash val="solid"/>
+          </a:ln>
+        </p:spPr>
+      </p:sp>
+      <p:sp>
+        <p:nvSpPr>
+          <p:cNvPr id="15" name="Text 13"/>
+          <p:cNvSpPr txBox="1"/>
+          <p:nvPr/>
+        </p:nvSpPr>
+        <p:spPr>
+          <a:xfrm>
+            <a:off x="2887822" y="990844"/>
+            <a:ext cx="8592288" cy="198754"/>
+          </a:xfrm>
+          <a:prstGeom prst="rect">
+            <a:avLst/>
+          </a:prstGeom>
+          <a:noFill/>
+          <a:ln/>
+        </p:spPr>
+        <p:txBody>
+          <a:bodyPr wrap="square" lIns="0" tIns="0" rIns="0" bIns="0" rtlCol="0" anchor="ctr"/>
+          <a:lstStyle/>
+          <a:p>
+            <a:pPr indent="0" marL="0">
+              <a:buNone/>
+            </a:pPr>
+            <a:r>
+              <a:rPr lang="en-US" sz="1050" b="1" dirty="0">
+                <a:solidFill>
+                  <a:srgbClr val="1D2D3E"/>
+                </a:solidFill>
+                <a:latin typeface="Arial" pitchFamily="34" charset="0"/>
+                <a:ea typeface="Arial" pitchFamily="34" charset="-122"/>
+                <a:cs typeface="Arial" pitchFamily="34" charset="-120"/>
+              </a:rPr>
+              <a:t>Customer data center / private network</a:t>
+            </a:r>
+            <a:endParaRPr lang="en-US" sz="1050" dirty="0"/>
+          </a:p>
+        </p:txBody>
+      </p:sp>
+      <p:sp>
+        <p:nvSpPr>
+          <p:cNvPr id="16" name="Shape 14"/>
+          <p:cNvSpPr/>
+          <p:nvPr/>
+        </p:nvSpPr>
+        <p:spPr>
+          <a:xfrm>
+            <a:off x="2994843" y="1602395"/>
+            <a:ext cx="1528877" cy="840882"/>
+          </a:xfrm>
+          <a:prstGeom prst="roundRect">
+            <a:avLst>
+              <a:gd name="adj" fmla="val 6525"/>
+            </a:avLst>
+          </a:prstGeom>
+          <a:solidFill>
+            <a:srgbClr val="FFFFFF"/>
+          </a:solidFill>
+          <a:ln w="9525">
+            <a:solidFill>
+              <a:srgbClr val="475E75"/>
+            </a:solidFill>
+            <a:prstDash val="solid"/>
+          </a:ln>
+        </p:spPr>
+      </p:sp>
+      <p:sp>
+        <p:nvSpPr>
+          <p:cNvPr id="17" name="Text 15"/>
+          <p:cNvSpPr txBox="1"/>
+          <p:nvPr/>
+        </p:nvSpPr>
+        <p:spPr>
+          <a:xfrm>
+            <a:off x="3346485" y="1678838"/>
+            <a:ext cx="1116080" cy="214043"/>
+          </a:xfrm>
+          <a:prstGeom prst="rect">
+            <a:avLst/>
+          </a:prstGeom>
+          <a:noFill/>
+          <a:ln/>
+        </p:spPr>
+        <p:txBody>
+          <a:bodyPr wrap="square" lIns="0" tIns="0" rIns="0" bIns="0" rtlCol="0" anchor="ctr"/>
+          <a:lstStyle/>
+          <a:p>
+            <a:pPr indent="0" marL="0">
+              <a:buNone/>
+            </a:pPr>
+            <a:r>
+              <a:rPr lang="en-US" sz="1000" b="1" dirty="0">
+                <a:solidFill>
+                  <a:srgbClr val="1D2D3E"/>
+                </a:solidFill>
+                <a:latin typeface="Arial" pitchFamily="34" charset="0"/>
+                <a:ea typeface="Arial" pitchFamily="34" charset="-122"/>
+                <a:cs typeface="Arial" pitchFamily="34" charset="-120"/>
+              </a:rPr>
+              <a:t>Reverse proxy</a:t>
+            </a:r>
+            <a:endParaRPr lang="en-US" sz="1000" dirty="0"/>
+          </a:p>
+        </p:txBody>
+      </p:sp>
+      <p:sp>
+        <p:nvSpPr>
+          <p:cNvPr id="18" name="Text 16"/>
+          <p:cNvSpPr txBox="1"/>
+          <p:nvPr/>
+        </p:nvSpPr>
+        <p:spPr>
+          <a:xfrm>
+            <a:off x="3101864" y="1938747"/>
+            <a:ext cx="1360700" cy="321064"/>
+          </a:xfrm>
+          <a:prstGeom prst="rect">
+            <a:avLst/>
+          </a:prstGeom>
+          <a:noFill/>
+          <a:ln/>
+        </p:spPr>
+        <p:txBody>
+          <a:bodyPr wrap="square" lIns="0" tIns="0" rIns="0" bIns="0" rtlCol="0" anchor="t"/>
+          <a:lstStyle/>
+          <a:p>
+            <a:pPr indent="0" marL="0">
+              <a:lnSpc>
+                <a:spcPct val="105000"/>
+              </a:lnSpc>
+              <a:buNone/>
+            </a:pPr>
+            <a:r>
+              <a:rPr lang="en-US" sz="850" dirty="0">
+                <a:solidFill>
+                  <a:srgbClr val="556B82"/>
+                </a:solidFill>
+                <a:latin typeface="Arial" pitchFamily="34" charset="0"/>
+                <a:ea typeface="Arial" pitchFamily="34" charset="-122"/>
+                <a:cs typeface="Arial" pitchFamily="34" charset="-120"/>
+              </a:rPr>
+              <a:t>HTTPS / TLS termination</a:t>
+            </a:r>
+            <a:endParaRPr lang="en-US" sz="850" dirty="0"/>
+          </a:p>
+          <a:p>
+            <a:pPr indent="0" marL="0">
+              <a:lnSpc>
+                <a:spcPct val="105000"/>
+              </a:lnSpc>
+              <a:buNone/>
+            </a:pPr>
+            <a:r>
+              <a:rPr lang="en-US" sz="850" dirty="0">
+                <a:solidFill>
+                  <a:srgbClr val="556B82"/>
+                </a:solidFill>
+                <a:latin typeface="Arial" pitchFamily="34" charset="0"/>
+                <a:ea typeface="Arial" pitchFamily="34" charset="-122"/>
+                <a:cs typeface="Arial" pitchFamily="34" charset="-120"/>
+              </a:rPr>
+              <a:t>nginx, IIS, Caddy, …</a:t>
+            </a:r>
+            <a:endParaRPr lang="en-US" sz="850" dirty="0"/>
+          </a:p>
+        </p:txBody>
+      </p:sp>
+      <p:sp>
+        <p:nvSpPr>
+          <p:cNvPr id="19" name="Shape 17"/>
+          <p:cNvSpPr/>
+          <p:nvPr/>
+        </p:nvSpPr>
+        <p:spPr>
+          <a:xfrm>
+            <a:off x="4905939" y="1487729"/>
+            <a:ext cx="1987540" cy="1719986"/>
+          </a:xfrm>
+          <a:prstGeom prst="roundRect">
+            <a:avLst>
+              <a:gd name="adj" fmla="val 3190"/>
+            </a:avLst>
+          </a:prstGeom>
+          <a:solidFill>
+            <a:srgbClr val="FFFFFF"/>
+          </a:solidFill>
+          <a:ln w="9525">
+            <a:solidFill>
+              <a:srgbClr val="475E75"/>
+            </a:solidFill>
+            <a:prstDash val="solid"/>
+          </a:ln>
+        </p:spPr>
+      </p:sp>
+      <p:sp>
+        <p:nvSpPr>
+          <p:cNvPr id="20" name="Text 18"/>
+          <p:cNvSpPr txBox="1"/>
+          <p:nvPr/>
+        </p:nvSpPr>
+        <p:spPr>
+          <a:xfrm>
+            <a:off x="5257581" y="1564173"/>
+            <a:ext cx="1574743" cy="214043"/>
+          </a:xfrm>
+          <a:prstGeom prst="rect">
+            <a:avLst/>
+          </a:prstGeom>
+          <a:noFill/>
+          <a:ln/>
+        </p:spPr>
+        <p:txBody>
+          <a:bodyPr wrap="square" lIns="0" tIns="0" rIns="0" bIns="0" rtlCol="0" anchor="ctr"/>
+          <a:lstStyle/>
+          <a:p>
+            <a:pPr indent="0" marL="0">
+              <a:buNone/>
+            </a:pPr>
+            <a:r>
+              <a:rPr lang="en-US" sz="1000" b="1" dirty="0">
+                <a:solidFill>
+                  <a:srgbClr val="1D2D3E"/>
+                </a:solidFill>
+                <a:latin typeface="Arial" pitchFamily="34" charset="0"/>
+                <a:ea typeface="Arial" pitchFamily="34" charset="-122"/>
+                <a:cs typeface="Arial" pitchFamily="34" charset="-120"/>
+              </a:rPr>
+              <a:t>odata-mcp-proxy</a:t>
+            </a:r>
+            <a:endParaRPr lang="en-US" sz="1000" dirty="0"/>
+          </a:p>
+        </p:txBody>
+      </p:sp>
+      <p:sp>
+        <p:nvSpPr>
+          <p:cNvPr id="21" name="Text 19"/>
+          <p:cNvSpPr txBox="1"/>
+          <p:nvPr/>
+        </p:nvSpPr>
+        <p:spPr>
+          <a:xfrm>
+            <a:off x="5012960" y="1824082"/>
+            <a:ext cx="1819363" cy="871460"/>
+          </a:xfrm>
+          <a:prstGeom prst="rect">
+            <a:avLst/>
+          </a:prstGeom>
+          <a:noFill/>
+          <a:ln/>
+        </p:spPr>
+        <p:txBody>
+          <a:bodyPr wrap="square" lIns="0" tIns="0" rIns="0" bIns="0" rtlCol="0" anchor="t"/>
+          <a:lstStyle/>
+          <a:p>
+            <a:pPr indent="0" marL="0">
+              <a:lnSpc>
+                <a:spcPct val="105000"/>
+              </a:lnSpc>
+              <a:buNone/>
+            </a:pPr>
+            <a:r>
+              <a:rPr lang="en-US" sz="850" dirty="0">
+                <a:solidFill>
+                  <a:srgbClr val="556B82"/>
+                </a:solidFill>
+                <a:latin typeface="Arial" pitchFamily="34" charset="0"/>
+                <a:ea typeface="Arial" pitchFamily="34" charset="-122"/>
+                <a:cs typeface="Arial" pitchFamily="34" charset="-120"/>
+              </a:rPr>
+              <a:t>Node.js server (systemd, Docker)</a:t>
+            </a:r>
+            <a:endParaRPr lang="en-US" sz="850" dirty="0"/>
+          </a:p>
+          <a:p>
+            <a:pPr indent="0" marL="0">
+              <a:lnSpc>
+                <a:spcPct val="105000"/>
+              </a:lnSpc>
+              <a:buNone/>
+            </a:pPr>
+            <a:r>
+              <a:rPr lang="en-US" sz="850" dirty="0">
+                <a:solidFill>
+                  <a:srgbClr val="556B82"/>
+                </a:solidFill>
+                <a:latin typeface="Arial" pitchFamily="34" charset="0"/>
+                <a:ea typeface="Arial" pitchFamily="34" charset="-122"/>
+                <a:cs typeface="Arial" pitchFamily="34" charset="-120"/>
+              </a:rPr>
+              <a:t>/mcp  Streamable HTTP</a:t>
+            </a:r>
+            <a:endParaRPr lang="en-US" sz="850" dirty="0"/>
+          </a:p>
+          <a:p>
+            <a:pPr indent="0" marL="0">
+              <a:lnSpc>
+                <a:spcPct val="105000"/>
+              </a:lnSpc>
+              <a:buNone/>
+            </a:pPr>
+            <a:r>
+              <a:rPr lang="en-US" sz="850" dirty="0">
+                <a:solidFill>
+                  <a:srgbClr val="556B82"/>
+                </a:solidFill>
+                <a:latin typeface="Arial" pitchFamily="34" charset="0"/>
+                <a:ea typeface="Arial" pitchFamily="34" charset="-122"/>
+                <a:cs typeface="Arial" pitchFamily="34" charset="-120"/>
+              </a:rPr>
+              <a:t>/oauth/*  OAuth proxy</a:t>
+            </a:r>
+            <a:endParaRPr lang="en-US" sz="850" dirty="0"/>
+          </a:p>
+          <a:p>
+            <a:pPr indent="0" marL="0">
+              <a:lnSpc>
+                <a:spcPct val="105000"/>
+              </a:lnSpc>
+              <a:buNone/>
+            </a:pPr>
+            <a:r>
+              <a:rPr lang="en-US" sz="850" dirty="0">
+                <a:solidFill>
+                  <a:srgbClr val="556B82"/>
+                </a:solidFill>
+                <a:latin typeface="Arial" pitchFamily="34" charset="0"/>
+                <a:ea typeface="Arial" pitchFamily="34" charset="-122"/>
+                <a:cs typeface="Arial" pitchFamily="34" charset="-120"/>
+              </a:rPr>
+              <a:t>OIDC JWT validation (JWKS)</a:t>
+            </a:r>
+            <a:endParaRPr lang="en-US" sz="850" dirty="0"/>
+          </a:p>
+          <a:p>
+            <a:pPr indent="0" marL="0">
+              <a:lnSpc>
+                <a:spcPct val="105000"/>
+              </a:lnSpc>
+              <a:buNone/>
+            </a:pPr>
+            <a:r>
+              <a:rPr lang="en-US" sz="850" dirty="0">
+                <a:solidFill>
+                  <a:srgbClr val="556B82"/>
+                </a:solidFill>
+                <a:latin typeface="Arial" pitchFamily="34" charset="0"/>
+                <a:ea typeface="Arial" pitchFamily="34" charset="-122"/>
+                <a:cs typeface="Arial" pitchFamily="34" charset="-120"/>
+              </a:rPr>
+              <a:t>Per-user token cache</a:t>
+            </a:r>
+            <a:endParaRPr lang="en-US" sz="850" dirty="0"/>
+          </a:p>
+          <a:p>
+            <a:pPr indent="0" marL="0">
+              <a:lnSpc>
+                <a:spcPct val="105000"/>
+              </a:lnSpc>
+              <a:buNone/>
+            </a:pPr>
+            <a:r>
+              <a:rPr lang="en-US" sz="850" dirty="0">
+                <a:solidFill>
+                  <a:srgbClr val="556B82"/>
+                </a:solidFill>
+                <a:latin typeface="Arial" pitchFamily="34" charset="0"/>
+                <a:ea typeface="Arial" pitchFamily="34" charset="-122"/>
+                <a:cs typeface="Arial" pitchFamily="34" charset="-120"/>
+              </a:rPr>
+              <a:t>SAML assertion signing</a:t>
+            </a:r>
+            <a:endParaRPr lang="en-US" sz="850" dirty="0"/>
+          </a:p>
+        </p:txBody>
+      </p:sp>
+      <p:sp>
+        <p:nvSpPr>
+          <p:cNvPr id="22" name="Shape 20"/>
+          <p:cNvSpPr/>
+          <p:nvPr/>
+        </p:nvSpPr>
+        <p:spPr>
+          <a:xfrm>
+            <a:off x="4905939" y="3628156"/>
+            <a:ext cx="1528877" cy="687995"/>
+          </a:xfrm>
+          <a:prstGeom prst="roundRect">
+            <a:avLst>
+              <a:gd name="adj" fmla="val 7974"/>
+            </a:avLst>
+          </a:prstGeom>
+          <a:solidFill>
+            <a:srgbClr val="FFFFFF"/>
+          </a:solidFill>
+          <a:ln w="9525">
+            <a:solidFill>
+              <a:srgbClr val="475E75"/>
+            </a:solidFill>
+            <a:prstDash val="solid"/>
+          </a:ln>
+        </p:spPr>
+      </p:sp>
+      <p:sp>
+        <p:nvSpPr>
+          <p:cNvPr id="23" name="Text 21"/>
+          <p:cNvSpPr txBox="1"/>
+          <p:nvPr/>
+        </p:nvSpPr>
+        <p:spPr>
+          <a:xfrm>
+            <a:off x="5257581" y="3704600"/>
+            <a:ext cx="1116080" cy="214043"/>
+          </a:xfrm>
+          <a:prstGeom prst="rect">
+            <a:avLst/>
+          </a:prstGeom>
+          <a:noFill/>
+          <a:ln/>
+        </p:spPr>
+        <p:txBody>
+          <a:bodyPr wrap="square" lIns="0" tIns="0" rIns="0" bIns="0" rtlCol="0" anchor="ctr"/>
+          <a:lstStyle/>
+          <a:p>
+            <a:pPr indent="0" marL="0">
+              <a:buNone/>
+            </a:pPr>
+            <a:r>
+              <a:rPr lang="en-US" sz="1000" b="1" dirty="0">
+                <a:solidFill>
+                  <a:srgbClr val="1D2D3E"/>
+                </a:solidFill>
+                <a:latin typeface="Arial" pitchFamily="34" charset="0"/>
+                <a:ea typeface="Arial" pitchFamily="34" charset="-122"/>
+                <a:cs typeface="Arial" pitchFamily="34" charset="-120"/>
+              </a:rPr>
+              <a:t>Secret store</a:t>
+            </a:r>
+            <a:endParaRPr lang="en-US" sz="1000" dirty="0"/>
+          </a:p>
+        </p:txBody>
+      </p:sp>
+      <p:sp>
+        <p:nvSpPr>
+          <p:cNvPr id="24" name="Text 22"/>
+          <p:cNvSpPr txBox="1"/>
+          <p:nvPr/>
+        </p:nvSpPr>
+        <p:spPr>
+          <a:xfrm>
+            <a:off x="5012960" y="3964509"/>
+            <a:ext cx="1360700" cy="321064"/>
+          </a:xfrm>
+          <a:prstGeom prst="rect">
+            <a:avLst/>
+          </a:prstGeom>
+          <a:noFill/>
+          <a:ln/>
+        </p:spPr>
+        <p:txBody>
+          <a:bodyPr wrap="square" lIns="0" tIns="0" rIns="0" bIns="0" rtlCol="0" anchor="t"/>
+          <a:lstStyle/>
+          <a:p>
+            <a:pPr indent="0" marL="0">
+              <a:lnSpc>
+                <a:spcPct val="105000"/>
+              </a:lnSpc>
+              <a:buNone/>
+            </a:pPr>
+            <a:r>
+              <a:rPr lang="en-US" sz="850" dirty="0">
+                <a:solidFill>
+                  <a:srgbClr val="556B82"/>
+                </a:solidFill>
+                <a:latin typeface="Arial" pitchFamily="34" charset="0"/>
+                <a:ea typeface="Arial" pitchFamily="34" charset="-122"/>
+                <a:cs typeface="Arial" pitchFamily="34" charset="-120"/>
+              </a:rPr>
+              <a:t>SAML signing key,</a:t>
+            </a:r>
+            <a:endParaRPr lang="en-US" sz="850" dirty="0"/>
+          </a:p>
+          <a:p>
+            <a:pPr indent="0" marL="0">
+              <a:lnSpc>
+                <a:spcPct val="105000"/>
+              </a:lnSpc>
+              <a:buNone/>
+            </a:pPr>
+            <a:r>
+              <a:rPr lang="en-US" sz="850" dirty="0">
+                <a:solidFill>
+                  <a:srgbClr val="556B82"/>
+                </a:solidFill>
+                <a:latin typeface="Arial" pitchFamily="34" charset="0"/>
+                <a:ea typeface="Arial" pitchFamily="34" charset="-122"/>
+                <a:cs typeface="Arial" pitchFamily="34" charset="-120"/>
+              </a:rPr>
+              <a:t>client secrets</a:t>
+            </a:r>
+            <a:endParaRPr lang="en-US" sz="850" dirty="0"/>
+          </a:p>
+        </p:txBody>
+      </p:sp>
+      <p:sp>
+        <p:nvSpPr>
+          <p:cNvPr id="25" name="Shape 23"/>
+          <p:cNvSpPr/>
+          <p:nvPr/>
+        </p:nvSpPr>
+        <p:spPr>
+          <a:xfrm>
+            <a:off x="7619695" y="1258397"/>
+            <a:ext cx="3745748" cy="3325307"/>
+          </a:xfrm>
+          <a:prstGeom prst="roundRect">
+            <a:avLst>
+              <a:gd name="adj" fmla="val 2750"/>
+            </a:avLst>
+          </a:prstGeom>
+          <a:solidFill>
+            <a:srgbClr val="FFFFFF"/>
+          </a:solidFill>
+          <a:ln w="9525">
+            <a:solidFill>
+              <a:srgbClr val="475E75"/>
+            </a:solidFill>
+            <a:prstDash val="dash"/>
+          </a:ln>
+        </p:spPr>
+      </p:sp>
+      <p:sp>
+        <p:nvSpPr>
+          <p:cNvPr id="26" name="Text 24"/>
+          <p:cNvSpPr txBox="1"/>
+          <p:nvPr/>
+        </p:nvSpPr>
+        <p:spPr>
+          <a:xfrm>
+            <a:off x="7742005" y="1334841"/>
+            <a:ext cx="3546994" cy="198754"/>
+          </a:xfrm>
+          <a:prstGeom prst="rect">
+            <a:avLst/>
+          </a:prstGeom>
+          <a:noFill/>
+          <a:ln/>
+        </p:spPr>
+        <p:txBody>
+          <a:bodyPr wrap="square" lIns="0" tIns="0" rIns="0" bIns="0" rtlCol="0" anchor="ctr"/>
+          <a:lstStyle/>
+          <a:p>
+            <a:pPr indent="0" marL="0">
+              <a:buNone/>
+            </a:pPr>
+            <a:r>
+              <a:rPr lang="en-US" sz="900" b="1" dirty="0">
+                <a:solidFill>
+                  <a:srgbClr val="475E75"/>
+                </a:solidFill>
+                <a:latin typeface="Arial" pitchFamily="34" charset="0"/>
+                <a:ea typeface="Arial" pitchFamily="34" charset="-122"/>
+                <a:cs typeface="Arial" pitchFamily="34" charset="-120"/>
+              </a:rPr>
+              <a:t>SAP landscape</a:t>
+            </a:r>
+            <a:endParaRPr lang="en-US" sz="900" dirty="0"/>
+          </a:p>
+        </p:txBody>
+      </p:sp>
+      <p:sp>
+        <p:nvSpPr>
+          <p:cNvPr id="27" name="Shape 25"/>
+          <p:cNvSpPr/>
+          <p:nvPr/>
+        </p:nvSpPr>
+        <p:spPr>
+          <a:xfrm>
+            <a:off x="7849027" y="1602395"/>
+            <a:ext cx="3287085" cy="1261323"/>
+          </a:xfrm>
+          <a:prstGeom prst="roundRect">
+            <a:avLst>
+              <a:gd name="adj" fmla="val 4350"/>
+            </a:avLst>
+          </a:prstGeom>
+          <a:solidFill>
+            <a:srgbClr val="FFFFFF"/>
+          </a:solidFill>
+          <a:ln w="9525">
+            <a:solidFill>
+              <a:srgbClr val="475E75"/>
+            </a:solidFill>
+            <a:prstDash val="solid"/>
+          </a:ln>
+        </p:spPr>
+      </p:sp>
+      <p:sp>
+        <p:nvSpPr>
+          <p:cNvPr id="28" name="Text 26"/>
+          <p:cNvSpPr txBox="1"/>
+          <p:nvPr/>
+        </p:nvSpPr>
+        <p:spPr>
+          <a:xfrm>
+            <a:off x="8200668" y="1678838"/>
+            <a:ext cx="2874288" cy="214043"/>
+          </a:xfrm>
+          <a:prstGeom prst="rect">
+            <a:avLst/>
+          </a:prstGeom>
+          <a:noFill/>
+          <a:ln/>
+        </p:spPr>
+        <p:txBody>
+          <a:bodyPr wrap="square" lIns="0" tIns="0" rIns="0" bIns="0" rtlCol="0" anchor="ctr"/>
+          <a:lstStyle/>
+          <a:p>
+            <a:pPr indent="0" marL="0">
+              <a:buNone/>
+            </a:pPr>
+            <a:r>
+              <a:rPr lang="en-US" sz="1000" b="1" dirty="0">
+                <a:solidFill>
+                  <a:srgbClr val="1D2D3E"/>
+                </a:solidFill>
+                <a:latin typeface="Arial" pitchFamily="34" charset="0"/>
+                <a:ea typeface="Arial" pitchFamily="34" charset="-122"/>
+                <a:cs typeface="Arial" pitchFamily="34" charset="-120"/>
+              </a:rPr>
+              <a:t>SAP S/4HANA</a:t>
+            </a:r>
+            <a:endParaRPr lang="en-US" sz="1000" dirty="0"/>
+          </a:p>
+        </p:txBody>
+      </p:sp>
+      <p:sp>
+        <p:nvSpPr>
+          <p:cNvPr id="29" name="Text 27"/>
+          <p:cNvSpPr txBox="1"/>
+          <p:nvPr/>
+        </p:nvSpPr>
+        <p:spPr>
+          <a:xfrm>
+            <a:off x="7956048" y="1938747"/>
+            <a:ext cx="3118909" cy="596262"/>
+          </a:xfrm>
+          <a:prstGeom prst="rect">
+            <a:avLst/>
+          </a:prstGeom>
+          <a:noFill/>
+          <a:ln/>
+        </p:spPr>
+        <p:txBody>
+          <a:bodyPr wrap="square" lIns="0" tIns="0" rIns="0" bIns="0" rtlCol="0" anchor="t"/>
+          <a:lstStyle/>
+          <a:p>
+            <a:pPr indent="0" marL="0">
+              <a:lnSpc>
+                <a:spcPct val="105000"/>
+              </a:lnSpc>
+              <a:buNone/>
+            </a:pPr>
+            <a:r>
+              <a:rPr lang="en-US" sz="850" dirty="0">
+                <a:solidFill>
+                  <a:srgbClr val="556B82"/>
+                </a:solidFill>
+                <a:latin typeface="Arial" pitchFamily="34" charset="0"/>
+                <a:ea typeface="Arial" pitchFamily="34" charset="-122"/>
+                <a:cs typeface="Arial" pitchFamily="34" charset="-120"/>
+              </a:rPr>
+              <a:t>OAuth 2.0 server (SOAUTH2)</a:t>
+            </a:r>
+            <a:endParaRPr lang="en-US" sz="850" dirty="0"/>
+          </a:p>
+          <a:p>
+            <a:pPr indent="0" marL="0">
+              <a:lnSpc>
+                <a:spcPct val="105000"/>
+              </a:lnSpc>
+              <a:buNone/>
+            </a:pPr>
+            <a:r>
+              <a:rPr lang="en-US" sz="850" dirty="0">
+                <a:solidFill>
+                  <a:srgbClr val="556B82"/>
+                </a:solidFill>
+                <a:latin typeface="Arial" pitchFamily="34" charset="0"/>
+                <a:ea typeface="Arial" pitchFamily="34" charset="-122"/>
+                <a:cs typeface="Arial" pitchFamily="34" charset="-120"/>
+              </a:rPr>
+              <a:t>SAML2 trusted provider: the proxy</a:t>
+            </a:r>
+            <a:endParaRPr lang="en-US" sz="850" dirty="0"/>
+          </a:p>
+          <a:p>
+            <a:pPr indent="0" marL="0">
+              <a:lnSpc>
+                <a:spcPct val="105000"/>
+              </a:lnSpc>
+              <a:buNone/>
+            </a:pPr>
+            <a:r>
+              <a:rPr lang="en-US" sz="850" dirty="0">
+                <a:solidFill>
+                  <a:srgbClr val="556B82"/>
+                </a:solidFill>
+                <a:latin typeface="Arial" pitchFamily="34" charset="0"/>
+                <a:ea typeface="Arial" pitchFamily="34" charset="-122"/>
+                <a:cs typeface="Arial" pitchFamily="34" charset="-120"/>
+              </a:rPr>
+              <a:t>User mapping by e-mail or user ID</a:t>
+            </a:r>
+            <a:endParaRPr lang="en-US" sz="850" dirty="0"/>
+          </a:p>
+          <a:p>
+            <a:pPr indent="0" marL="0">
+              <a:lnSpc>
+                <a:spcPct val="105000"/>
+              </a:lnSpc>
+              <a:buNone/>
+            </a:pPr>
+            <a:r>
+              <a:rPr lang="en-US" sz="850" dirty="0">
+                <a:solidFill>
+                  <a:srgbClr val="556B82"/>
+                </a:solidFill>
+                <a:latin typeface="Arial" pitchFamily="34" charset="0"/>
+                <a:ea typeface="Arial" pitchFamily="34" charset="-122"/>
+                <a:cs typeface="Arial" pitchFamily="34" charset="-120"/>
+              </a:rPr>
+              <a:t>OData services run as the business user</a:t>
+            </a:r>
+            <a:endParaRPr lang="en-US" sz="850" dirty="0"/>
+          </a:p>
+        </p:txBody>
+      </p:sp>
+      <p:sp>
+        <p:nvSpPr>
+          <p:cNvPr id="30" name="Shape 28"/>
+          <p:cNvSpPr/>
+          <p:nvPr/>
+        </p:nvSpPr>
+        <p:spPr>
+          <a:xfrm>
+            <a:off x="7849027" y="3284159"/>
+            <a:ext cx="3287085" cy="993770"/>
+          </a:xfrm>
+          <a:prstGeom prst="roundRect">
+            <a:avLst>
+              <a:gd name="adj" fmla="val 5521"/>
+            </a:avLst>
+          </a:prstGeom>
+          <a:solidFill>
+            <a:srgbClr val="FFFFFF"/>
+          </a:solidFill>
+          <a:ln w="9525">
+            <a:solidFill>
+              <a:srgbClr val="475E75"/>
+            </a:solidFill>
+            <a:prstDash val="solid"/>
+          </a:ln>
+        </p:spPr>
+      </p:sp>
+      <p:sp>
+        <p:nvSpPr>
+          <p:cNvPr id="31" name="Text 29"/>
+          <p:cNvSpPr txBox="1"/>
+          <p:nvPr/>
+        </p:nvSpPr>
+        <p:spPr>
+          <a:xfrm>
+            <a:off x="8200668" y="3360603"/>
+            <a:ext cx="2874288" cy="214043"/>
+          </a:xfrm>
+          <a:prstGeom prst="rect">
+            <a:avLst/>
+          </a:prstGeom>
+          <a:noFill/>
+          <a:ln/>
+        </p:spPr>
+        <p:txBody>
+          <a:bodyPr wrap="square" lIns="0" tIns="0" rIns="0" bIns="0" rtlCol="0" anchor="ctr"/>
+          <a:lstStyle/>
+          <a:p>
+            <a:pPr indent="0" marL="0">
+              <a:buNone/>
+            </a:pPr>
+            <a:r>
+              <a:rPr lang="en-US" sz="1000" b="1" dirty="0">
+                <a:solidFill>
+                  <a:srgbClr val="1D2D3E"/>
+                </a:solidFill>
+                <a:latin typeface="Arial" pitchFamily="34" charset="0"/>
+                <a:ea typeface="Arial" pitchFamily="34" charset="-122"/>
+                <a:cs typeface="Arial" pitchFamily="34" charset="-120"/>
+              </a:rPr>
+              <a:t>Other SAP ABAP systems</a:t>
+            </a:r>
+            <a:endParaRPr lang="en-US" sz="1000" dirty="0"/>
+          </a:p>
+        </p:txBody>
+      </p:sp>
+      <p:sp>
+        <p:nvSpPr>
+          <p:cNvPr id="32" name="Text 30"/>
+          <p:cNvSpPr txBox="1"/>
+          <p:nvPr/>
+        </p:nvSpPr>
+        <p:spPr>
+          <a:xfrm>
+            <a:off x="7956048" y="3620512"/>
+            <a:ext cx="3118909" cy="321064"/>
+          </a:xfrm>
+          <a:prstGeom prst="rect">
+            <a:avLst/>
+          </a:prstGeom>
+          <a:noFill/>
+          <a:ln/>
+        </p:spPr>
+        <p:txBody>
+          <a:bodyPr wrap="square" lIns="0" tIns="0" rIns="0" bIns="0" rtlCol="0" anchor="t"/>
+          <a:lstStyle/>
+          <a:p>
+            <a:pPr indent="0" marL="0">
+              <a:lnSpc>
+                <a:spcPct val="105000"/>
+              </a:lnSpc>
+              <a:buNone/>
+            </a:pPr>
+            <a:r>
+              <a:rPr lang="en-US" sz="850" dirty="0">
+                <a:solidFill>
+                  <a:srgbClr val="556B82"/>
+                </a:solidFill>
+                <a:latin typeface="Arial" pitchFamily="34" charset="0"/>
+                <a:ea typeface="Arial" pitchFamily="34" charset="-122"/>
+                <a:cs typeface="Arial" pitchFamily="34" charset="-120"/>
+              </a:rPr>
+              <a:t>SAP ECC, BW/4HANA, Gateway hub, …</a:t>
+            </a:r>
+            <a:endParaRPr lang="en-US" sz="850" dirty="0"/>
+          </a:p>
+          <a:p>
+            <a:pPr indent="0" marL="0">
+              <a:lnSpc>
+                <a:spcPct val="105000"/>
+              </a:lnSpc>
+              <a:buNone/>
+            </a:pPr>
+            <a:r>
+              <a:rPr lang="en-US" sz="850" dirty="0">
+                <a:solidFill>
+                  <a:srgbClr val="556B82"/>
+                </a:solidFill>
+                <a:latin typeface="Arial" pitchFamily="34" charset="0"/>
+                <a:ea typeface="Arial" pitchFamily="34" charset="-122"/>
+                <a:cs typeface="Arial" pitchFamily="34" charset="-120"/>
+              </a:rPr>
+              <a:t>Same trust set-up, one destination each</a:t>
+            </a:r>
+            <a:endParaRPr lang="en-US" sz="850" dirty="0"/>
+          </a:p>
+        </p:txBody>
+      </p:sp>
+      <p:sp>
+        <p:nvSpPr>
+          <p:cNvPr id="33" name="Shape 31"/>
+          <p:cNvSpPr/>
+          <p:nvPr/>
+        </p:nvSpPr>
+        <p:spPr>
+          <a:xfrm>
+            <a:off x="7849027" y="4813036"/>
+            <a:ext cx="3516417" cy="840882"/>
+          </a:xfrm>
+          <a:prstGeom prst="roundRect">
+            <a:avLst>
+              <a:gd name="adj" fmla="val 6525"/>
+            </a:avLst>
+          </a:prstGeom>
+          <a:solidFill>
+            <a:srgbClr val="FFFFFF"/>
+          </a:solidFill>
+          <a:ln w="9525">
+            <a:solidFill>
+              <a:srgbClr val="475E75"/>
+            </a:solidFill>
+            <a:prstDash val="solid"/>
+          </a:ln>
+        </p:spPr>
+      </p:sp>
+      <p:sp>
+        <p:nvSpPr>
+          <p:cNvPr id="34" name="Text 32"/>
+          <p:cNvSpPr txBox="1"/>
+          <p:nvPr/>
+        </p:nvSpPr>
+        <p:spPr>
+          <a:xfrm>
+            <a:off x="8200668" y="4889480"/>
+            <a:ext cx="3103620" cy="214043"/>
+          </a:xfrm>
+          <a:prstGeom prst="rect">
+            <a:avLst/>
+          </a:prstGeom>
+          <a:noFill/>
+          <a:ln/>
+        </p:spPr>
+        <p:txBody>
+          <a:bodyPr wrap="square" lIns="0" tIns="0" rIns="0" bIns="0" rtlCol="0" anchor="ctr"/>
+          <a:lstStyle/>
+          <a:p>
+            <a:pPr indent="0" marL="0">
+              <a:buNone/>
+            </a:pPr>
+            <a:r>
+              <a:rPr lang="en-US" sz="1000" b="1" dirty="0">
+                <a:solidFill>
+                  <a:srgbClr val="1D2D3E"/>
+                </a:solidFill>
+                <a:latin typeface="Arial" pitchFamily="34" charset="0"/>
+                <a:ea typeface="Arial" pitchFamily="34" charset="-122"/>
+                <a:cs typeface="Arial" pitchFamily="34" charset="-120"/>
+              </a:rPr>
+              <a:t>Per-destination configuration</a:t>
+            </a:r>
+            <a:endParaRPr lang="en-US" sz="1000" dirty="0"/>
+          </a:p>
+        </p:txBody>
+      </p:sp>
+      <p:sp>
+        <p:nvSpPr>
+          <p:cNvPr id="35" name="Text 33"/>
+          <p:cNvSpPr txBox="1"/>
+          <p:nvPr/>
+        </p:nvSpPr>
+        <p:spPr>
+          <a:xfrm>
+            <a:off x="7956048" y="5149389"/>
+            <a:ext cx="3348240" cy="321064"/>
+          </a:xfrm>
+          <a:prstGeom prst="rect">
+            <a:avLst/>
+          </a:prstGeom>
+          <a:noFill/>
+          <a:ln/>
+        </p:spPr>
+        <p:txBody>
+          <a:bodyPr wrap="square" lIns="0" tIns="0" rIns="0" bIns="0" rtlCol="0" anchor="t"/>
+          <a:lstStyle/>
+          <a:p>
+            <a:pPr indent="0" marL="0">
+              <a:lnSpc>
+                <a:spcPct val="105000"/>
+              </a:lnSpc>
+              <a:buNone/>
+            </a:pPr>
+            <a:r>
+              <a:rPr lang="en-US" sz="850" dirty="0">
+                <a:solidFill>
+                  <a:srgbClr val="556B82"/>
+                </a:solidFill>
+                <a:latin typeface="Arial" pitchFamily="34" charset="0"/>
+                <a:ea typeface="Arial" pitchFamily="34" charset="-122"/>
+                <a:cs typeface="Arial" pitchFamily="34" charset="-120"/>
+              </a:rPr>
+              <a:t>{PREFIX}_AUTH_TYPE = saml-bearer  (per user)</a:t>
+            </a:r>
+            <a:endParaRPr lang="en-US" sz="850" dirty="0"/>
+          </a:p>
+          <a:p>
+            <a:pPr indent="0" marL="0">
+              <a:lnSpc>
+                <a:spcPct val="105000"/>
+              </a:lnSpc>
+              <a:buNone/>
+            </a:pPr>
+            <a:r>
+              <a:rPr lang="en-US" sz="850" dirty="0">
+                <a:solidFill>
+                  <a:srgbClr val="556B82"/>
+                </a:solidFill>
+                <a:latin typeface="Arial" pitchFamily="34" charset="0"/>
+                <a:ea typeface="Arial" pitchFamily="34" charset="-122"/>
+                <a:cs typeface="Arial" pitchFamily="34" charset="-120"/>
+              </a:rPr>
+              <a:t>or client-credentials (technical user)</a:t>
+            </a:r>
+            <a:endParaRPr lang="en-US" sz="850" dirty="0"/>
+          </a:p>
+        </p:txBody>
+      </p:sp>
+      <p:sp>
+        <p:nvSpPr>
+          <p:cNvPr id="36" name="Shape 34"/>
+          <p:cNvSpPr/>
+          <p:nvPr/>
+        </p:nvSpPr>
+        <p:spPr>
+          <a:xfrm>
+            <a:off x="2306848" y="2022836"/>
+            <a:ext cx="687995" cy="0"/>
+          </a:xfrm>
+          <a:prstGeom prst="line">
+            <a:avLst/>
+          </a:prstGeom>
+          <a:noFill/>
+          <a:ln w="15875">
+            <a:solidFill>
+              <a:srgbClr val="475E75"/>
+            </a:solidFill>
+            <a:prstDash val="solid"/>
+            <a:tailEnd type="triangle"/>
+          </a:ln>
+        </p:spPr>
+      </p:sp>
+      <p:sp>
+        <p:nvSpPr>
+          <p:cNvPr id="37" name="Shape 35"/>
+          <p:cNvSpPr/>
+          <p:nvPr/>
+        </p:nvSpPr>
+        <p:spPr>
+          <a:xfrm>
+            <a:off x="4523720" y="2022836"/>
+            <a:ext cx="382219" cy="0"/>
+          </a:xfrm>
+          <a:prstGeom prst="line">
+            <a:avLst/>
+          </a:prstGeom>
+          <a:noFill/>
+          <a:ln w="15875">
+            <a:solidFill>
+              <a:srgbClr val="475E75"/>
+            </a:solidFill>
+            <a:prstDash val="solid"/>
+            <a:tailEnd type="triangle"/>
+          </a:ln>
+        </p:spPr>
+      </p:sp>
+      <p:sp>
+        <p:nvSpPr>
+          <p:cNvPr id="38" name="Text 36"/>
+          <p:cNvSpPr/>
+          <p:nvPr/>
+        </p:nvSpPr>
+        <p:spPr>
+          <a:xfrm>
+            <a:off x="2570580" y="1942570"/>
+            <a:ext cx="160532" cy="160532"/>
+          </a:xfrm>
+          <a:prstGeom prst="ellipse">
+            <a:avLst/>
+          </a:prstGeom>
+          <a:solidFill>
+            <a:srgbClr val="1D2D3E"/>
+          </a:solidFill>
+          <a:ln w="6350">
+            <a:solidFill>
+              <a:srgbClr val="1D2D3E"/>
+            </a:solidFill>
+          </a:ln>
+        </p:spPr>
+        <p:txBody>
+          <a:bodyPr wrap="square" lIns="0" tIns="0" rIns="0" bIns="0" rtlCol="0" anchor="ctr"/>
+          <a:lstStyle/>
+          <a:p>
+            <a:pPr algn="ctr" indent="0" marL="0">
+              <a:buNone/>
+            </a:pPr>
+            <a:r>
+              <a:rPr lang="en-US" sz="800" b="1" dirty="0">
+                <a:solidFill>
+                  <a:srgbClr val="FFFFFF"/>
+                </a:solidFill>
+                <a:latin typeface="Arial" pitchFamily="34" charset="0"/>
+                <a:ea typeface="Arial" pitchFamily="34" charset="-122"/>
+                <a:cs typeface="Arial" pitchFamily="34" charset="-120"/>
+              </a:rPr>
+              <a:t>1</a:t>
+            </a:r>
+            <a:endParaRPr lang="en-US" sz="800" dirty="0"/>
+          </a:p>
+        </p:txBody>
+      </p:sp>
+      <p:sp>
+        <p:nvSpPr>
+          <p:cNvPr id="39" name="Shape 37"/>
+          <p:cNvSpPr/>
+          <p:nvPr/>
+        </p:nvSpPr>
+        <p:spPr>
+          <a:xfrm flipH="1">
+            <a:off x="4714829" y="2978384"/>
+            <a:ext cx="191110" cy="0"/>
+          </a:xfrm>
+          <a:prstGeom prst="line">
+            <a:avLst/>
+          </a:prstGeom>
+          <a:noFill/>
+          <a:ln w="15875">
+            <a:solidFill>
+              <a:srgbClr val="5D36FF"/>
+            </a:solidFill>
+            <a:prstDash val="dash"/>
+          </a:ln>
+        </p:spPr>
+      </p:sp>
+      <p:sp>
+        <p:nvSpPr>
+          <p:cNvPr id="40" name="Shape 38"/>
+          <p:cNvSpPr/>
+          <p:nvPr/>
+        </p:nvSpPr>
+        <p:spPr>
+          <a:xfrm>
+            <a:off x="4714829" y="2978384"/>
+            <a:ext cx="0" cy="2178649"/>
+          </a:xfrm>
+          <a:prstGeom prst="line">
+            <a:avLst/>
+          </a:prstGeom>
+          <a:noFill/>
+          <a:ln w="15875">
+            <a:solidFill>
+              <a:srgbClr val="5D36FF"/>
+            </a:solidFill>
+            <a:prstDash val="dash"/>
+          </a:ln>
+        </p:spPr>
+      </p:sp>
+      <p:sp>
+        <p:nvSpPr>
+          <p:cNvPr id="41" name="Shape 39"/>
+          <p:cNvSpPr/>
+          <p:nvPr/>
+        </p:nvSpPr>
+        <p:spPr>
+          <a:xfrm flipH="1">
+            <a:off x="2306848" y="5157033"/>
+            <a:ext cx="2407981" cy="0"/>
+          </a:xfrm>
+          <a:prstGeom prst="line">
+            <a:avLst/>
+          </a:prstGeom>
+          <a:noFill/>
+          <a:ln w="15875">
+            <a:solidFill>
+              <a:srgbClr val="5D36FF"/>
+            </a:solidFill>
+            <a:prstDash val="dash"/>
+            <a:tailEnd type="triangle"/>
+          </a:ln>
+        </p:spPr>
+      </p:sp>
+      <p:sp>
+        <p:nvSpPr>
+          <p:cNvPr id="42" name="Text 40"/>
+          <p:cNvSpPr/>
+          <p:nvPr/>
+        </p:nvSpPr>
+        <p:spPr>
+          <a:xfrm>
+            <a:off x="4634563" y="3968331"/>
+            <a:ext cx="160532" cy="160532"/>
+          </a:xfrm>
+          <a:prstGeom prst="ellipse">
+            <a:avLst/>
+          </a:prstGeom>
+          <a:solidFill>
+            <a:srgbClr val="1D2D3E"/>
+          </a:solidFill>
+          <a:ln w="6350">
+            <a:solidFill>
+              <a:srgbClr val="1D2D3E"/>
+            </a:solidFill>
+          </a:ln>
+        </p:spPr>
+        <p:txBody>
+          <a:bodyPr wrap="square" lIns="0" tIns="0" rIns="0" bIns="0" rtlCol="0" anchor="ctr"/>
+          <a:lstStyle/>
+          <a:p>
+            <a:pPr algn="ctr" indent="0" marL="0">
+              <a:buNone/>
+            </a:pPr>
+            <a:r>
+              <a:rPr lang="en-US" sz="800" b="1" dirty="0">
+                <a:solidFill>
+                  <a:srgbClr val="FFFFFF"/>
+                </a:solidFill>
+                <a:latin typeface="Arial" pitchFamily="34" charset="0"/>
+                <a:ea typeface="Arial" pitchFamily="34" charset="-122"/>
+                <a:cs typeface="Arial" pitchFamily="34" charset="-120"/>
+              </a:rPr>
+              <a:t>2</a:t>
+            </a:r>
+            <a:endParaRPr lang="en-US" sz="800" dirty="0"/>
+          </a:p>
+        </p:txBody>
+      </p:sp>
+      <p:sp>
+        <p:nvSpPr>
+          <p:cNvPr id="43" name="Text 41"/>
+          <p:cNvSpPr txBox="1"/>
+          <p:nvPr/>
+        </p:nvSpPr>
+        <p:spPr>
+          <a:xfrm>
+            <a:off x="2612624" y="4965924"/>
+            <a:ext cx="1834652" cy="114666"/>
+          </a:xfrm>
+          <a:prstGeom prst="rect">
+            <a:avLst/>
+          </a:prstGeom>
+          <a:noFill/>
+          <a:ln/>
+        </p:spPr>
+        <p:txBody>
+          <a:bodyPr wrap="square" lIns="0" tIns="0" rIns="0" bIns="0" rtlCol="0" anchor="ctr"/>
+          <a:lstStyle/>
+          <a:p>
+            <a:pPr algn="ctr" indent="0" marL="0">
+              <a:buNone/>
+            </a:pPr>
+            <a:r>
+              <a:rPr lang="en-US" sz="750" dirty="0">
+                <a:solidFill>
+                  <a:srgbClr val="556B82"/>
+                </a:solidFill>
+                <a:latin typeface="Arial" pitchFamily="34" charset="0"/>
+                <a:ea typeface="Arial" pitchFamily="34" charset="-122"/>
+                <a:cs typeface="Arial" pitchFamily="34" charset="-120"/>
+              </a:rPr>
+              <a:t>OIDC login (proxied) · JWKS</a:t>
+            </a:r>
+            <a:endParaRPr lang="en-US" sz="750" dirty="0"/>
+          </a:p>
+        </p:txBody>
+      </p:sp>
+      <p:sp>
+        <p:nvSpPr>
+          <p:cNvPr id="44" name="Shape 42"/>
+          <p:cNvSpPr/>
+          <p:nvPr/>
+        </p:nvSpPr>
+        <p:spPr>
+          <a:xfrm>
+            <a:off x="5670377" y="3207715"/>
+            <a:ext cx="0" cy="420441"/>
+          </a:xfrm>
+          <a:prstGeom prst="line">
+            <a:avLst/>
+          </a:prstGeom>
+          <a:noFill/>
+          <a:ln w="15875">
+            <a:solidFill>
+              <a:srgbClr val="5D36FF"/>
+            </a:solidFill>
+            <a:prstDash val="dash"/>
+            <a:headEnd type="triangle"/>
+            <a:tailEnd type="triangle"/>
+          </a:ln>
+        </p:spPr>
+      </p:sp>
+      <p:sp>
+        <p:nvSpPr>
+          <p:cNvPr id="45" name="Shape 43"/>
+          <p:cNvSpPr/>
+          <p:nvPr/>
+        </p:nvSpPr>
+        <p:spPr>
+          <a:xfrm>
+            <a:off x="6893479" y="1984614"/>
+            <a:ext cx="955548" cy="0"/>
+          </a:xfrm>
+          <a:prstGeom prst="line">
+            <a:avLst/>
+          </a:prstGeom>
+          <a:noFill/>
+          <a:ln w="15875">
+            <a:solidFill>
+              <a:srgbClr val="5D36FF"/>
+            </a:solidFill>
+            <a:prstDash val="dash"/>
+            <a:tailEnd type="triangle"/>
+          </a:ln>
+        </p:spPr>
+      </p:sp>
+      <p:sp>
+        <p:nvSpPr>
+          <p:cNvPr id="46" name="Text 44"/>
+          <p:cNvSpPr/>
+          <p:nvPr/>
+        </p:nvSpPr>
+        <p:spPr>
+          <a:xfrm>
+            <a:off x="7287164" y="1904348"/>
+            <a:ext cx="160532" cy="160532"/>
+          </a:xfrm>
+          <a:prstGeom prst="ellipse">
+            <a:avLst/>
+          </a:prstGeom>
+          <a:solidFill>
+            <a:srgbClr val="1D2D3E"/>
+          </a:solidFill>
+          <a:ln w="6350">
+            <a:solidFill>
+              <a:srgbClr val="1D2D3E"/>
+            </a:solidFill>
+          </a:ln>
+        </p:spPr>
+        <p:txBody>
+          <a:bodyPr wrap="square" lIns="0" tIns="0" rIns="0" bIns="0" rtlCol="0" anchor="ctr"/>
+          <a:lstStyle/>
+          <a:p>
+            <a:pPr algn="ctr" indent="0" marL="0">
+              <a:buNone/>
+            </a:pPr>
+            <a:r>
+              <a:rPr lang="en-US" sz="800" b="1" dirty="0">
+                <a:solidFill>
+                  <a:srgbClr val="FFFFFF"/>
+                </a:solidFill>
+                <a:latin typeface="Arial" pitchFamily="34" charset="0"/>
+                <a:ea typeface="Arial" pitchFamily="34" charset="-122"/>
+                <a:cs typeface="Arial" pitchFamily="34" charset="-120"/>
+              </a:rPr>
+              <a:t>3</a:t>
+            </a:r>
+            <a:endParaRPr lang="en-US" sz="800" dirty="0"/>
+          </a:p>
+        </p:txBody>
+      </p:sp>
+      <p:sp>
+        <p:nvSpPr>
+          <p:cNvPr id="47" name="Text 45"/>
+          <p:cNvSpPr txBox="1"/>
+          <p:nvPr/>
+        </p:nvSpPr>
+        <p:spPr>
+          <a:xfrm>
+            <a:off x="6946989" y="1778215"/>
+            <a:ext cx="687995" cy="114666"/>
+          </a:xfrm>
+          <a:prstGeom prst="rect">
+            <a:avLst/>
+          </a:prstGeom>
+          <a:noFill/>
+          <a:ln/>
+        </p:spPr>
+        <p:txBody>
+          <a:bodyPr wrap="square" lIns="0" tIns="0" rIns="0" bIns="0" rtlCol="0" anchor="ctr"/>
+          <a:lstStyle/>
+          <a:p>
+            <a:pPr algn="ctr" indent="0" marL="0">
+              <a:buNone/>
+            </a:pPr>
+            <a:r>
+              <a:rPr lang="en-US" sz="750" dirty="0">
+                <a:solidFill>
+                  <a:srgbClr val="556B82"/>
+                </a:solidFill>
+                <a:latin typeface="Arial" pitchFamily="34" charset="0"/>
+                <a:ea typeface="Arial" pitchFamily="34" charset="-122"/>
+                <a:cs typeface="Arial" pitchFamily="34" charset="-120"/>
+              </a:rPr>
+              <a:t>SAML bearer</a:t>
+            </a:r>
+            <a:endParaRPr lang="en-US" sz="750" dirty="0"/>
+          </a:p>
+        </p:txBody>
+      </p:sp>
+      <p:sp>
+        <p:nvSpPr>
+          <p:cNvPr id="48" name="Shape 46"/>
+          <p:cNvSpPr/>
+          <p:nvPr/>
+        </p:nvSpPr>
+        <p:spPr>
+          <a:xfrm>
+            <a:off x="6893479" y="2596164"/>
+            <a:ext cx="955548" cy="0"/>
+          </a:xfrm>
+          <a:prstGeom prst="line">
+            <a:avLst/>
+          </a:prstGeom>
+          <a:noFill/>
+          <a:ln w="15875">
+            <a:solidFill>
+              <a:srgbClr val="475E75"/>
+            </a:solidFill>
+            <a:prstDash val="solid"/>
+            <a:tailEnd type="triangle"/>
+          </a:ln>
+        </p:spPr>
+      </p:sp>
+      <p:sp>
+        <p:nvSpPr>
+          <p:cNvPr id="49" name="Text 47"/>
+          <p:cNvSpPr/>
+          <p:nvPr/>
+        </p:nvSpPr>
+        <p:spPr>
+          <a:xfrm>
+            <a:off x="7287164" y="2515898"/>
+            <a:ext cx="160532" cy="160532"/>
+          </a:xfrm>
+          <a:prstGeom prst="ellipse">
+            <a:avLst/>
+          </a:prstGeom>
+          <a:solidFill>
+            <a:srgbClr val="1D2D3E"/>
+          </a:solidFill>
+          <a:ln w="6350">
+            <a:solidFill>
+              <a:srgbClr val="1D2D3E"/>
+            </a:solidFill>
+          </a:ln>
+        </p:spPr>
+        <p:txBody>
+          <a:bodyPr wrap="square" lIns="0" tIns="0" rIns="0" bIns="0" rtlCol="0" anchor="ctr"/>
+          <a:lstStyle/>
+          <a:p>
+            <a:pPr algn="ctr" indent="0" marL="0">
+              <a:buNone/>
+            </a:pPr>
+            <a:r>
+              <a:rPr lang="en-US" sz="800" b="1" dirty="0">
+                <a:solidFill>
+                  <a:srgbClr val="FFFFFF"/>
+                </a:solidFill>
+                <a:latin typeface="Arial" pitchFamily="34" charset="0"/>
+                <a:ea typeface="Arial" pitchFamily="34" charset="-122"/>
+                <a:cs typeface="Arial" pitchFamily="34" charset="-120"/>
+              </a:rPr>
+              <a:t>4</a:t>
+            </a:r>
+            <a:endParaRPr lang="en-US" sz="800" dirty="0"/>
+          </a:p>
+        </p:txBody>
+      </p:sp>
+      <p:sp>
+        <p:nvSpPr>
+          <p:cNvPr id="50" name="Text 48"/>
+          <p:cNvSpPr txBox="1"/>
+          <p:nvPr/>
+        </p:nvSpPr>
+        <p:spPr>
+          <a:xfrm>
+            <a:off x="6946989" y="2389766"/>
+            <a:ext cx="687995" cy="114666"/>
+          </a:xfrm>
+          <a:prstGeom prst="rect">
+            <a:avLst/>
+          </a:prstGeom>
+          <a:noFill/>
+          <a:ln/>
+        </p:spPr>
+        <p:txBody>
+          <a:bodyPr wrap="square" lIns="0" tIns="0" rIns="0" bIns="0" rtlCol="0" anchor="ctr"/>
+          <a:lstStyle/>
+          <a:p>
+            <a:pPr algn="ctr" indent="0" marL="0">
+              <a:buNone/>
+            </a:pPr>
+            <a:r>
+              <a:rPr lang="en-US" sz="750" dirty="0">
+                <a:solidFill>
+                  <a:srgbClr val="556B82"/>
+                </a:solidFill>
+                <a:latin typeface="Arial" pitchFamily="34" charset="0"/>
+                <a:ea typeface="Arial" pitchFamily="34" charset="-122"/>
+                <a:cs typeface="Arial" pitchFamily="34" charset="-120"/>
+              </a:rPr>
+              <a:t>OData</a:t>
+            </a:r>
+            <a:endParaRPr lang="en-US" sz="750" dirty="0"/>
+          </a:p>
+        </p:txBody>
+      </p:sp>
+      <p:sp>
+        <p:nvSpPr>
+          <p:cNvPr id="51" name="Shape 49"/>
+          <p:cNvSpPr/>
+          <p:nvPr/>
+        </p:nvSpPr>
+        <p:spPr>
+          <a:xfrm>
+            <a:off x="6893479" y="3054828"/>
+            <a:ext cx="343997" cy="0"/>
+          </a:xfrm>
+          <a:prstGeom prst="line">
+            <a:avLst/>
+          </a:prstGeom>
+          <a:noFill/>
+          <a:ln w="15875">
+            <a:solidFill>
+              <a:srgbClr val="475E75"/>
+            </a:solidFill>
+            <a:prstDash val="solid"/>
+          </a:ln>
+        </p:spPr>
+      </p:sp>
+      <p:sp>
+        <p:nvSpPr>
+          <p:cNvPr id="52" name="Shape 50"/>
+          <p:cNvSpPr/>
+          <p:nvPr/>
+        </p:nvSpPr>
+        <p:spPr>
+          <a:xfrm>
+            <a:off x="7237476" y="3054828"/>
+            <a:ext cx="0" cy="726216"/>
+          </a:xfrm>
+          <a:prstGeom prst="line">
+            <a:avLst/>
+          </a:prstGeom>
+          <a:noFill/>
+          <a:ln w="15875">
+            <a:solidFill>
+              <a:srgbClr val="475E75"/>
+            </a:solidFill>
+            <a:prstDash val="solid"/>
+          </a:ln>
+        </p:spPr>
+      </p:sp>
+      <p:sp>
+        <p:nvSpPr>
+          <p:cNvPr id="53" name="Shape 51"/>
+          <p:cNvSpPr/>
+          <p:nvPr/>
+        </p:nvSpPr>
+        <p:spPr>
+          <a:xfrm>
+            <a:off x="7237476" y="3781044"/>
+            <a:ext cx="611551" cy="0"/>
+          </a:xfrm>
+          <a:prstGeom prst="line">
+            <a:avLst/>
+          </a:prstGeom>
+          <a:noFill/>
+          <a:ln w="15875">
+            <a:solidFill>
+              <a:srgbClr val="475E75"/>
+            </a:solidFill>
+            <a:prstDash val="solid"/>
+            <a:tailEnd type="triangle"/>
+          </a:ln>
+        </p:spPr>
+      </p:sp>
+      <p:sp>
+        <p:nvSpPr>
+          <p:cNvPr id="54" name="Text 52"/>
+          <p:cNvSpPr/>
+          <p:nvPr/>
+        </p:nvSpPr>
+        <p:spPr>
+          <a:xfrm>
+            <a:off x="7157210" y="3341492"/>
+            <a:ext cx="160532" cy="160532"/>
+          </a:xfrm>
+          <a:prstGeom prst="ellipse">
+            <a:avLst/>
+          </a:prstGeom>
+          <a:solidFill>
+            <a:srgbClr val="1D2D3E"/>
+          </a:solidFill>
+          <a:ln w="6350">
+            <a:solidFill>
+              <a:srgbClr val="1D2D3E"/>
+            </a:solidFill>
+          </a:ln>
+        </p:spPr>
+        <p:txBody>
+          <a:bodyPr wrap="square" lIns="0" tIns="0" rIns="0" bIns="0" rtlCol="0" anchor="ctr"/>
+          <a:lstStyle/>
+          <a:p>
+            <a:pPr algn="ctr" indent="0" marL="0">
+              <a:buNone/>
+            </a:pPr>
+            <a:r>
+              <a:rPr lang="en-US" sz="800" b="1" dirty="0">
+                <a:solidFill>
+                  <a:srgbClr val="FFFFFF"/>
+                </a:solidFill>
+                <a:latin typeface="Arial" pitchFamily="34" charset="0"/>
+                <a:ea typeface="Arial" pitchFamily="34" charset="-122"/>
+                <a:cs typeface="Arial" pitchFamily="34" charset="-120"/>
+              </a:rPr>
+              <a:t>5</a:t>
+            </a:r>
+            <a:endParaRPr lang="en-US" sz="800" dirty="0"/>
+          </a:p>
+        </p:txBody>
+      </p:sp>
+      <p:sp>
+        <p:nvSpPr>
+          <p:cNvPr id="55" name="Shape 53"/>
+          <p:cNvSpPr/>
+          <p:nvPr/>
+        </p:nvSpPr>
+        <p:spPr>
+          <a:xfrm>
+            <a:off x="548640" y="6446520"/>
+            <a:ext cx="292608" cy="155448"/>
+          </a:xfrm>
+          <a:prstGeom prst="roundRect">
+            <a:avLst>
+              <a:gd name="adj" fmla="val 23529"/>
+            </a:avLst>
+          </a:prstGeom>
+          <a:solidFill>
+            <a:srgbClr val="F5F6F7"/>
+          </a:solidFill>
+          <a:ln w="12700">
+            <a:solidFill>
+              <a:srgbClr val="475E75"/>
+            </a:solidFill>
+            <a:prstDash val="solid"/>
+          </a:ln>
+        </p:spPr>
+      </p:sp>
+      <p:sp>
+        <p:nvSpPr>
+          <p:cNvPr id="56" name="Text 54"/>
+          <p:cNvSpPr txBox="1"/>
+          <p:nvPr/>
+        </p:nvSpPr>
+        <p:spPr>
+          <a:xfrm>
+            <a:off x="932688" y="6419088"/>
+            <a:ext cx="1828800" cy="210312"/>
+          </a:xfrm>
+          <a:prstGeom prst="rect">
+            <a:avLst/>
+          </a:prstGeom>
+          <a:noFill/>
+          <a:ln/>
+        </p:spPr>
+        <p:txBody>
+          <a:bodyPr wrap="square" lIns="0" tIns="0" rIns="0" bIns="0" rtlCol="0" anchor="ctr"/>
+          <a:lstStyle/>
+          <a:p>
+            <a:pPr indent="0" marL="0">
+              <a:buNone/>
+            </a:pPr>
+            <a:r>
+              <a:rPr lang="en-US" sz="900" dirty="0">
+                <a:solidFill>
+                  <a:srgbClr val="1D2D3E"/>
+                </a:solidFill>
+                <a:latin typeface="Arial" pitchFamily="34" charset="0"/>
+                <a:ea typeface="Arial" pitchFamily="34" charset="-122"/>
+                <a:cs typeface="Arial" pitchFamily="34" charset="-120"/>
+              </a:rPr>
+              <a:t>Non-SAP / customer</a:t>
+            </a:r>
+            <a:endParaRPr lang="en-US" sz="900" dirty="0"/>
+          </a:p>
+        </p:txBody>
+      </p:sp>
+      <p:sp>
+        <p:nvSpPr>
+          <p:cNvPr id="57" name="Shape 55"/>
+          <p:cNvSpPr/>
+          <p:nvPr/>
+        </p:nvSpPr>
+        <p:spPr>
+          <a:xfrm>
+            <a:off x="2273198" y="6524244"/>
+            <a:ext cx="292608" cy="0"/>
+          </a:xfrm>
+          <a:prstGeom prst="line">
+            <a:avLst/>
+          </a:prstGeom>
+          <a:noFill/>
+          <a:ln w="15875">
+            <a:solidFill>
+              <a:srgbClr val="475E75"/>
+            </a:solidFill>
+            <a:prstDash val="solid"/>
+            <a:tailEnd type="triangle"/>
+          </a:ln>
+        </p:spPr>
+      </p:sp>
+      <p:sp>
+        <p:nvSpPr>
+          <p:cNvPr id="58" name="Text 56"/>
+          <p:cNvSpPr txBox="1"/>
+          <p:nvPr/>
+        </p:nvSpPr>
+        <p:spPr>
+          <a:xfrm>
+            <a:off x="2657246" y="6419088"/>
+            <a:ext cx="1828800" cy="210312"/>
+          </a:xfrm>
+          <a:prstGeom prst="rect">
+            <a:avLst/>
+          </a:prstGeom>
+          <a:noFill/>
+          <a:ln/>
+        </p:spPr>
+        <p:txBody>
+          <a:bodyPr wrap="square" lIns="0" tIns="0" rIns="0" bIns="0" rtlCol="0" anchor="ctr"/>
+          <a:lstStyle/>
+          <a:p>
+            <a:pPr indent="0" marL="0">
+              <a:buNone/>
+            </a:pPr>
+            <a:r>
+              <a:rPr lang="en-US" sz="900" dirty="0">
+                <a:solidFill>
+                  <a:srgbClr val="1D2D3E"/>
+                </a:solidFill>
+                <a:latin typeface="Arial" pitchFamily="34" charset="0"/>
+                <a:ea typeface="Arial" pitchFamily="34" charset="-122"/>
+                <a:cs typeface="Arial" pitchFamily="34" charset="-120"/>
+              </a:rPr>
+              <a:t>API call / data flow</a:t>
+            </a:r>
+            <a:endParaRPr lang="en-US" sz="900" dirty="0"/>
+          </a:p>
+        </p:txBody>
+      </p:sp>
+      <p:sp>
+        <p:nvSpPr>
+          <p:cNvPr id="59" name="Shape 57"/>
+          <p:cNvSpPr/>
+          <p:nvPr/>
+        </p:nvSpPr>
+        <p:spPr>
+          <a:xfrm>
+            <a:off x="4111142" y="6524244"/>
+            <a:ext cx="292608" cy="0"/>
+          </a:xfrm>
+          <a:prstGeom prst="line">
+            <a:avLst/>
+          </a:prstGeom>
+          <a:noFill/>
+          <a:ln w="15875">
+            <a:solidFill>
+              <a:srgbClr val="5D36FF"/>
+            </a:solidFill>
+            <a:prstDash val="dash"/>
+            <a:tailEnd type="triangle"/>
+          </a:ln>
+        </p:spPr>
+      </p:sp>
+      <p:sp>
+        <p:nvSpPr>
+          <p:cNvPr id="60" name="Text 58"/>
+          <p:cNvSpPr txBox="1"/>
+          <p:nvPr/>
+        </p:nvSpPr>
+        <p:spPr>
+          <a:xfrm>
+            <a:off x="4495190" y="6419088"/>
+            <a:ext cx="1828800" cy="210312"/>
+          </a:xfrm>
+          <a:prstGeom prst="rect">
+            <a:avLst/>
+          </a:prstGeom>
+          <a:noFill/>
+          <a:ln/>
+        </p:spPr>
+        <p:txBody>
+          <a:bodyPr wrap="square" lIns="0" tIns="0" rIns="0" bIns="0" rtlCol="0" anchor="ctr"/>
+          <a:lstStyle/>
+          <a:p>
+            <a:pPr indent="0" marL="0">
+              <a:buNone/>
+            </a:pPr>
+            <a:r>
+              <a:rPr lang="en-US" sz="900" dirty="0">
+                <a:solidFill>
+                  <a:srgbClr val="1D2D3E"/>
+                </a:solidFill>
+                <a:latin typeface="Arial" pitchFamily="34" charset="0"/>
+                <a:ea typeface="Arial" pitchFamily="34" charset="-122"/>
+                <a:cs typeface="Arial" pitchFamily="34" charset="-120"/>
+              </a:rPr>
+              <a:t>Authentication / token flow</a:t>
+            </a:r>
+            <a:endParaRPr lang="en-US" sz="900" dirty="0"/>
+          </a:p>
+        </p:txBody>
+      </p:sp>
+      <p:sp>
+        <p:nvSpPr>
+          <p:cNvPr id="61" name="Text 59"/>
+          <p:cNvSpPr/>
+          <p:nvPr/>
+        </p:nvSpPr>
+        <p:spPr>
+          <a:xfrm>
+            <a:off x="6409944" y="6432804"/>
+            <a:ext cx="182880" cy="182880"/>
+          </a:xfrm>
+          <a:prstGeom prst="ellipse">
+            <a:avLst/>
+          </a:prstGeom>
+          <a:solidFill>
+            <a:srgbClr val="1D2D3E"/>
+          </a:solidFill>
+          <a:ln/>
+        </p:spPr>
+        <p:txBody>
+          <a:bodyPr wrap="square" lIns="0" tIns="0" rIns="0" bIns="0" rtlCol="0" anchor="ctr"/>
+          <a:lstStyle/>
+          <a:p>
+            <a:pPr algn="ctr" indent="0" marL="0">
+              <a:buNone/>
+            </a:pPr>
+            <a:r>
+              <a:rPr lang="en-US" sz="750" b="1" dirty="0">
+                <a:solidFill>
+                  <a:srgbClr val="FFFFFF"/>
+                </a:solidFill>
+                <a:latin typeface="Arial" pitchFamily="34" charset="0"/>
+                <a:ea typeface="Arial" pitchFamily="34" charset="-122"/>
+                <a:cs typeface="Arial" pitchFamily="34" charset="-120"/>
+              </a:rPr>
+              <a:t>1</a:t>
+            </a:r>
+            <a:endParaRPr lang="en-US" sz="750" dirty="0"/>
+          </a:p>
+        </p:txBody>
+      </p:sp>
+      <p:sp>
+        <p:nvSpPr>
+          <p:cNvPr id="62" name="Text 60"/>
+          <p:cNvSpPr txBox="1"/>
+          <p:nvPr/>
+        </p:nvSpPr>
+        <p:spPr>
+          <a:xfrm>
+            <a:off x="6729984" y="6419088"/>
+            <a:ext cx="1828800" cy="210312"/>
+          </a:xfrm>
+          <a:prstGeom prst="rect">
+            <a:avLst/>
+          </a:prstGeom>
+          <a:noFill/>
+          <a:ln/>
+        </p:spPr>
+        <p:txBody>
+          <a:bodyPr wrap="square" lIns="0" tIns="0" rIns="0" bIns="0" rtlCol="0" anchor="ctr"/>
+          <a:lstStyle/>
+          <a:p>
+            <a:pPr indent="0" marL="0">
+              <a:buNone/>
+            </a:pPr>
+            <a:r>
+              <a:rPr lang="en-US" sz="900" dirty="0">
+                <a:solidFill>
+                  <a:srgbClr val="1D2D3E"/>
+                </a:solidFill>
+                <a:latin typeface="Arial" pitchFamily="34" charset="0"/>
+                <a:ea typeface="Arial" pitchFamily="34" charset="-122"/>
+                <a:cs typeface="Arial" pitchFamily="34" charset="-120"/>
+              </a:rPr>
+              <a:t>Flow step (see next slide)</a:t>
+            </a:r>
+            <a:endParaRPr lang="en-US" sz="900" dirty="0"/>
+          </a:p>
+        </p:txBody>
+      </p:sp>
+      <p:pic>
+        <p:nvPicPr>
+          <p:cNvPr id="64" name="Image 0" descr="MCP client icon">    </p:cNvPr>
+          <p:cNvPicPr>
+            <a:picLocks noChangeAspect="1"/>
+          </p:cNvPicPr>
+          <p:nvPr/>
+        </p:nvPicPr>
+        <p:blipFill>
+          <a:blip r:embed="rId1"/>
+          <a:stretch>
+            <a:fillRect/>
+          </a:stretch>
+        </p:blipFill>
+        <p:spPr>
+          <a:xfrm>
+            <a:off x="793260" y="1533595"/>
+            <a:ext cx="198754" cy="198754"/>
+          </a:xfrm>
+          <a:prstGeom prst="rect">
+            <a:avLst/>
+          </a:prstGeom>
+        </p:spPr>
+      </p:pic>
+      <p:pic>
+        <p:nvPicPr>
+          <p:cNvPr id="65" name="Image 1" descr="Reverse proxy icon">    </p:cNvPr>
+          <p:cNvPicPr>
+            <a:picLocks noChangeAspect="1"/>
+          </p:cNvPicPr>
+          <p:nvPr/>
+        </p:nvPicPr>
+        <p:blipFill>
+          <a:blip r:embed="rId2"/>
+          <a:stretch>
+            <a:fillRect/>
+          </a:stretch>
+        </p:blipFill>
+        <p:spPr>
+          <a:xfrm>
+            <a:off x="3086575" y="1686483"/>
+            <a:ext cx="198754" cy="198754"/>
+          </a:xfrm>
+          <a:prstGeom prst="rect">
+            <a:avLst/>
+          </a:prstGeom>
+        </p:spPr>
+      </p:pic>
+      <p:pic>
+        <p:nvPicPr>
+          <p:cNvPr id="66" name="Image 2" descr="Any OIDC IdP icon">    </p:cNvPr>
+          <p:cNvPicPr>
+            <a:picLocks noChangeAspect="1"/>
+          </p:cNvPicPr>
+          <p:nvPr/>
+        </p:nvPicPr>
+        <p:blipFill>
+          <a:blip r:embed="rId3"/>
+          <a:stretch>
+            <a:fillRect/>
+          </a:stretch>
+        </p:blipFill>
+        <p:spPr>
+          <a:xfrm>
+            <a:off x="793260" y="4820680"/>
+            <a:ext cx="198754" cy="198754"/>
+          </a:xfrm>
+          <a:prstGeom prst="rect">
+            <a:avLst/>
+          </a:prstGeom>
+        </p:spPr>
+      </p:pic>
+      <p:pic>
+        <p:nvPicPr>
+          <p:cNvPr id="67" name="Image 3" descr="SAP S/4HANA icon">    </p:cNvPr>
+          <p:cNvPicPr>
+            <a:picLocks noChangeAspect="1"/>
+          </p:cNvPicPr>
+          <p:nvPr/>
+        </p:nvPicPr>
+        <p:blipFill>
+          <a:blip r:embed="rId4"/>
+          <a:stretch>
+            <a:fillRect/>
+          </a:stretch>
+        </p:blipFill>
+        <p:spPr>
+          <a:xfrm>
+            <a:off x="7940759" y="1686483"/>
+            <a:ext cx="198754" cy="198754"/>
+          </a:xfrm>
+          <a:prstGeom prst="rect">
+            <a:avLst/>
+          </a:prstGeom>
+        </p:spPr>
+      </p:pic>
+      <p:pic>
+        <p:nvPicPr>
+          <p:cNvPr id="68" name="Image 4" descr="odata-mcp-proxy icon">    </p:cNvPr>
+          <p:cNvPicPr>
+            <a:picLocks noChangeAspect="1"/>
+          </p:cNvPicPr>
+          <p:nvPr/>
+        </p:nvPicPr>
+        <p:blipFill>
+          <a:blip r:embed="rId5"/>
+          <a:stretch>
+            <a:fillRect/>
+          </a:stretch>
+        </p:blipFill>
+        <p:spPr>
+          <a:xfrm>
+            <a:off x="4997671" y="1571817"/>
+            <a:ext cx="198754" cy="198754"/>
+          </a:xfrm>
+          <a:prstGeom prst="rect">
+            <a:avLst/>
+          </a:prstGeom>
+        </p:spPr>
+      </p:pic>
+      <p:pic>
+        <p:nvPicPr>
+          <p:cNvPr id="69" name="Image 5" descr="Secret store icon">    </p:cNvPr>
+          <p:cNvPicPr>
+            <a:picLocks noChangeAspect="1"/>
+          </p:cNvPicPr>
+          <p:nvPr/>
+        </p:nvPicPr>
+        <p:blipFill>
+          <a:blip r:embed="rId6"/>
+          <a:stretch>
+            <a:fillRect/>
+          </a:stretch>
+        </p:blipFill>
+        <p:spPr>
+          <a:xfrm>
+            <a:off x="4997671" y="3712245"/>
+            <a:ext cx="198754" cy="198754"/>
+          </a:xfrm>
+          <a:prstGeom prst="rect">
+            <a:avLst/>
+          </a:prstGeom>
+        </p:spPr>
+      </p:pic>
+      <p:pic>
+        <p:nvPicPr>
+          <p:cNvPr id="70" name="Image 6" descr="Other SAP ABAP systems icon">    </p:cNvPr>
+          <p:cNvPicPr>
+            <a:picLocks noChangeAspect="1"/>
+          </p:cNvPicPr>
+          <p:nvPr/>
+        </p:nvPicPr>
+        <p:blipFill>
+          <a:blip r:embed="rId7"/>
+          <a:stretch>
+            <a:fillRect/>
+          </a:stretch>
+        </p:blipFill>
+        <p:spPr>
+          <a:xfrm>
+            <a:off x="7940759" y="3368247"/>
+            <a:ext cx="198754" cy="198754"/>
+          </a:xfrm>
+          <a:prstGeom prst="rect">
+            <a:avLst/>
+          </a:prstGeom>
+        </p:spPr>
+      </p:pic>
+      <p:pic>
+        <p:nvPicPr>
+          <p:cNvPr id="71" name="Image 7" descr="Per-destination configuration icon">    </p:cNvPr>
+          <p:cNvPicPr>
+            <a:picLocks noChangeAspect="1"/>
+          </p:cNvPicPr>
+          <p:nvPr/>
+        </p:nvPicPr>
+        <p:blipFill>
+          <a:blip r:embed="rId8"/>
+          <a:stretch>
+            <a:fillRect/>
+          </a:stretch>
+        </p:blipFill>
+        <p:spPr>
+          <a:xfrm>
+            <a:off x="7940759" y="4897124"/>
+            <a:ext cx="198754" cy="198754"/>
+          </a:xfrm>
+          <a:prstGeom prst="rect">
+            <a:avLst/>
+          </a:prstGeom>
+        </p:spPr>
+      </p:pic>
+    </p:spTree>
+  </p:cSld>
+  <p:clrMapOvr>
+    <a:masterClrMapping/>
+  </p:clrMapOvr>
+</p:sld>
+</file>
+
+<file path=ppt/slides/slide6.xml><?xml version="1.0" encoding="utf-8"?>
+<p:sld xmlns:a="http://schemas.openxmlformats.org/drawingml/2006/main" xmlns:r="http://schemas.openxmlformats.org/officeDocument/2006/relationships" xmlns:p="http://schemas.openxmlformats.org/presentationml/2006/main">
+  <p:cSld name="Slide 6">
+    <p:bg>
+      <p:bgPr>
+        <a:solidFill>
+          <a:srgbClr val="FFFFFF"/>
+        </a:solidFill>
+      </p:bgPr>
+    </p:bg>
+    <p:spTree>
+      <p:nvGrpSpPr>
+        <p:cNvPr id="1" name=""/>
+        <p:cNvGrpSpPr/>
+        <p:nvPr/>
+      </p:nvGrpSpPr>
+      <p:grpSpPr>
+        <a:xfrm>
+          <a:off x="0" y="0"/>
+          <a:ext cx="0" cy="0"/>
+          <a:chOff x="0" y="0"/>
+          <a:chExt cx="0" cy="0"/>
+        </a:xfrm>
+      </p:grpSpPr>
+      <p:sp>
+        <p:nvSpPr>
+          <p:cNvPr id="2" name="Text 0"/>
+          <p:cNvSpPr txBox="1"/>
+          <p:nvPr/>
+        </p:nvSpPr>
+        <p:spPr>
+          <a:xfrm>
+            <a:off x="548640" y="274320"/>
+            <a:ext cx="11064240" cy="411480"/>
+          </a:xfrm>
+          <a:prstGeom prst="rect">
+            <a:avLst/>
+          </a:prstGeom>
+          <a:noFill/>
+          <a:ln/>
+        </p:spPr>
+        <p:txBody>
+          <a:bodyPr wrap="square" lIns="0" tIns="0" rIns="0" bIns="0" rtlCol="0" anchor="ctr"/>
+          <a:lstStyle/>
+          <a:p>
+            <a:pPr indent="0" marL="0">
+              <a:buNone/>
+            </a:pPr>
+            <a:r>
+              <a:rPr lang="en-US" sz="2800" b="1" dirty="0">
+                <a:solidFill>
+                  <a:srgbClr val="1D2D3E"/>
+                </a:solidFill>
+                <a:latin typeface="Arial" pitchFamily="34" charset="0"/>
+                <a:ea typeface="Arial" pitchFamily="34" charset="-122"/>
+                <a:cs typeface="Arial" pitchFamily="34" charset="-120"/>
+              </a:rPr>
+              <a:t>Without SAP BTP — how a request flows</a:t>
+            </a:r>
+            <a:endParaRPr lang="en-US" sz="2800" dirty="0"/>
+          </a:p>
+        </p:txBody>
+      </p:sp>
+      <p:sp>
+        <p:nvSpPr>
+          <p:cNvPr id="3" name="Text 1"/>
+          <p:cNvSpPr txBox="1"/>
+          <p:nvPr/>
+        </p:nvSpPr>
+        <p:spPr>
+          <a:xfrm>
+            <a:off x="548640" y="685800"/>
+            <a:ext cx="11064240" cy="256032"/>
+          </a:xfrm>
+          <a:prstGeom prst="rect">
+            <a:avLst/>
+          </a:prstGeom>
+          <a:noFill/>
+          <a:ln/>
+        </p:spPr>
+        <p:txBody>
+          <a:bodyPr wrap="square" lIns="0" tIns="0" rIns="0" bIns="0" rtlCol="0" anchor="ctr"/>
+          <a:lstStyle/>
+          <a:p>
+            <a:pPr indent="0" marL="0">
+              <a:buNone/>
+            </a:pPr>
+            <a:r>
+              <a:rPr lang="en-US" sz="1100" dirty="0">
+                <a:solidFill>
+                  <a:srgbClr val="556B82"/>
+                </a:solidFill>
+                <a:latin typeface="Arial" pitchFamily="34" charset="0"/>
+                <a:ea typeface="Arial" pitchFamily="34" charset="-122"/>
+                <a:cs typeface="Arial" pitchFamily="34" charset="-120"/>
+              </a:rPr>
+              <a:t>Numbered steps match the diagram on the previous slide</a:t>
+            </a:r>
+            <a:endParaRPr lang="en-US" sz="1100" dirty="0"/>
+          </a:p>
+        </p:txBody>
+      </p:sp>
+      <p:sp>
+        <p:nvSpPr>
+          <p:cNvPr id="4" name="Shape 2"/>
+          <p:cNvSpPr/>
+          <p:nvPr/>
+        </p:nvSpPr>
+        <p:spPr>
+          <a:xfrm>
+            <a:off x="548640" y="1234440"/>
+            <a:ext cx="5394960" cy="1097280"/>
+          </a:xfrm>
+          <a:prstGeom prst="roundRect">
+            <a:avLst>
+              <a:gd name="adj" fmla="val 6667"/>
+            </a:avLst>
+          </a:prstGeom>
+          <a:solidFill>
+            <a:srgbClr val="F5F6F7"/>
+          </a:solidFill>
+          <a:ln w="9525">
+            <a:solidFill>
+              <a:srgbClr val="E1E6EB"/>
+            </a:solidFill>
+            <a:prstDash val="solid"/>
+          </a:ln>
+        </p:spPr>
+      </p:sp>
+      <p:sp>
+        <p:nvSpPr>
+          <p:cNvPr id="5" name="Text 3"/>
+          <p:cNvSpPr/>
+          <p:nvPr/>
+        </p:nvSpPr>
+        <p:spPr>
+          <a:xfrm>
+            <a:off x="777240" y="1508760"/>
+            <a:ext cx="420624" cy="420624"/>
+          </a:xfrm>
+          <a:prstGeom prst="ellipse">
+            <a:avLst/>
+          </a:prstGeom>
+          <a:solidFill>
+            <a:srgbClr val="1D2D3E"/>
+          </a:solidFill>
+          <a:ln/>
+        </p:spPr>
+        <p:txBody>
+          <a:bodyPr wrap="square" lIns="0" tIns="0" rIns="0" bIns="0" rtlCol="0" anchor="ctr"/>
+          <a:lstStyle/>
+          <a:p>
+            <a:pPr algn="ctr" indent="0" marL="0">
+              <a:buNone/>
+            </a:pPr>
+            <a:r>
+              <a:rPr lang="en-US" sz="1500" b="1" dirty="0">
+                <a:solidFill>
+                  <a:srgbClr val="FFFFFF"/>
+                </a:solidFill>
+                <a:latin typeface="Arial" pitchFamily="34" charset="0"/>
+                <a:ea typeface="Arial" pitchFamily="34" charset="-122"/>
+                <a:cs typeface="Arial" pitchFamily="34" charset="-120"/>
+              </a:rPr>
+              <a:t>1</a:t>
+            </a:r>
+            <a:endParaRPr lang="en-US" sz="1500" dirty="0"/>
+          </a:p>
+        </p:txBody>
+      </p:sp>
+      <p:sp>
+        <p:nvSpPr>
+          <p:cNvPr id="6" name="Text 4"/>
+          <p:cNvSpPr txBox="1"/>
+          <p:nvPr/>
+        </p:nvSpPr>
+        <p:spPr>
+          <a:xfrm>
+            <a:off x="1417320" y="1399032"/>
+            <a:ext cx="4297680" cy="292608"/>
+          </a:xfrm>
+          <a:prstGeom prst="rect">
+            <a:avLst/>
+          </a:prstGeom>
+          <a:noFill/>
+          <a:ln/>
+        </p:spPr>
+        <p:txBody>
+          <a:bodyPr wrap="square" lIns="0" tIns="0" rIns="0" bIns="0" rtlCol="0" anchor="ctr"/>
+          <a:lstStyle/>
+          <a:p>
+            <a:pPr indent="0" marL="0">
+              <a:buNone/>
+            </a:pPr>
+            <a:r>
+              <a:rPr lang="en-US" sz="1400" b="1" dirty="0">
+                <a:solidFill>
+                  <a:srgbClr val="1D2D3E"/>
+                </a:solidFill>
+                <a:latin typeface="Arial" pitchFamily="34" charset="0"/>
+                <a:ea typeface="Arial" pitchFamily="34" charset="-122"/>
+                <a:cs typeface="Arial" pitchFamily="34" charset="-120"/>
+              </a:rPr>
+              <a:t>MCP request</a:t>
+            </a:r>
+            <a:endParaRPr lang="en-US" sz="1400" dirty="0"/>
+          </a:p>
+        </p:txBody>
+      </p:sp>
+      <p:sp>
+        <p:nvSpPr>
+          <p:cNvPr id="7" name="Text 5"/>
+          <p:cNvSpPr txBox="1"/>
+          <p:nvPr/>
+        </p:nvSpPr>
+        <p:spPr>
+          <a:xfrm>
+            <a:off x="1417320" y="1709928"/>
+            <a:ext cx="4297680" cy="640080"/>
+          </a:xfrm>
+          <a:prstGeom prst="rect">
+            <a:avLst/>
+          </a:prstGeom>
+          <a:noFill/>
+          <a:ln/>
+        </p:spPr>
+        <p:txBody>
+          <a:bodyPr wrap="square" lIns="0" tIns="0" rIns="0" bIns="0" rtlCol="0" anchor="t"/>
+          <a:lstStyle/>
+          <a:p>
+            <a:pPr indent="0" marL="0">
+              <a:buNone/>
+            </a:pPr>
+            <a:r>
+              <a:rPr lang="en-US" sz="1100" dirty="0">
+                <a:solidFill>
+                  <a:srgbClr val="556B82"/>
+                </a:solidFill>
+                <a:latin typeface="Arial" pitchFamily="34" charset="0"/>
+                <a:ea typeface="Arial" pitchFamily="34" charset="-122"/>
+                <a:cs typeface="Arial" pitchFamily="34" charset="-120"/>
+              </a:rPr>
+              <a:t>Clients reach the Node.js server through a reverse proxy that terminates TLS. /mcp requires a bearer token.</a:t>
+            </a:r>
+            <a:endParaRPr lang="en-US" sz="1100" dirty="0"/>
+          </a:p>
+        </p:txBody>
+      </p:sp>
+      <p:sp>
+        <p:nvSpPr>
+          <p:cNvPr id="8" name="Shape 6"/>
+          <p:cNvSpPr/>
+          <p:nvPr/>
+        </p:nvSpPr>
+        <p:spPr>
+          <a:xfrm>
+            <a:off x="548640" y="2532888"/>
+            <a:ext cx="5394960" cy="1097280"/>
+          </a:xfrm>
+          <a:prstGeom prst="roundRect">
+            <a:avLst>
+              <a:gd name="adj" fmla="val 6667"/>
+            </a:avLst>
+          </a:prstGeom>
+          <a:solidFill>
+            <a:srgbClr val="F5F6F7"/>
+          </a:solidFill>
+          <a:ln w="9525">
+            <a:solidFill>
+              <a:srgbClr val="E1E6EB"/>
+            </a:solidFill>
+            <a:prstDash val="solid"/>
+          </a:ln>
+        </p:spPr>
+      </p:sp>
+      <p:sp>
+        <p:nvSpPr>
+          <p:cNvPr id="9" name="Text 7"/>
+          <p:cNvSpPr/>
+          <p:nvPr/>
+        </p:nvSpPr>
+        <p:spPr>
+          <a:xfrm>
+            <a:off x="777240" y="2807208"/>
+            <a:ext cx="420624" cy="420624"/>
+          </a:xfrm>
+          <a:prstGeom prst="ellipse">
+            <a:avLst/>
+          </a:prstGeom>
+          <a:solidFill>
+            <a:srgbClr val="1D2D3E"/>
+          </a:solidFill>
+          <a:ln/>
+        </p:spPr>
+        <p:txBody>
+          <a:bodyPr wrap="square" lIns="0" tIns="0" rIns="0" bIns="0" rtlCol="0" anchor="ctr"/>
+          <a:lstStyle/>
+          <a:p>
+            <a:pPr algn="ctr" indent="0" marL="0">
+              <a:buNone/>
+            </a:pPr>
+            <a:r>
+              <a:rPr lang="en-US" sz="1500" b="1" dirty="0">
+                <a:solidFill>
+                  <a:srgbClr val="FFFFFF"/>
+                </a:solidFill>
+                <a:latin typeface="Arial" pitchFamily="34" charset="0"/>
+                <a:ea typeface="Arial" pitchFamily="34" charset="-122"/>
+                <a:cs typeface="Arial" pitchFamily="34" charset="-120"/>
+              </a:rPr>
+              <a:t>2</a:t>
+            </a:r>
+            <a:endParaRPr lang="en-US" sz="1500" dirty="0"/>
+          </a:p>
+        </p:txBody>
+      </p:sp>
+      <p:sp>
+        <p:nvSpPr>
+          <p:cNvPr id="10" name="Text 8"/>
+          <p:cNvSpPr txBox="1"/>
+          <p:nvPr/>
+        </p:nvSpPr>
+        <p:spPr>
+          <a:xfrm>
+            <a:off x="1417320" y="2697480"/>
+            <a:ext cx="4297680" cy="292608"/>
+          </a:xfrm>
+          <a:prstGeom prst="rect">
+            <a:avLst/>
+          </a:prstGeom>
+          <a:noFill/>
+          <a:ln/>
+        </p:spPr>
+        <p:txBody>
+          <a:bodyPr wrap="square" lIns="0" tIns="0" rIns="0" bIns="0" rtlCol="0" anchor="ctr"/>
+          <a:lstStyle/>
+          <a:p>
+            <a:pPr indent="0" marL="0">
+              <a:buNone/>
+            </a:pPr>
+            <a:r>
+              <a:rPr lang="en-US" sz="1400" b="1" dirty="0">
+                <a:solidFill>
+                  <a:srgbClr val="1D2D3E"/>
+                </a:solidFill>
+                <a:latin typeface="Arial" pitchFamily="34" charset="0"/>
+                <a:ea typeface="Arial" pitchFamily="34" charset="-122"/>
+                <a:cs typeface="Arial" pitchFamily="34" charset="-120"/>
+              </a:rPr>
+              <a:t>Single sign-on with any OIDC IdP</a:t>
+            </a:r>
+            <a:endParaRPr lang="en-US" sz="1400" dirty="0"/>
+          </a:p>
+        </p:txBody>
+      </p:sp>
+      <p:sp>
+        <p:nvSpPr>
+          <p:cNvPr id="11" name="Text 9"/>
+          <p:cNvSpPr txBox="1"/>
+          <p:nvPr/>
+        </p:nvSpPr>
+        <p:spPr>
+          <a:xfrm>
+            <a:off x="1417320" y="3008376"/>
+            <a:ext cx="4297680" cy="640080"/>
+          </a:xfrm>
+          <a:prstGeom prst="rect">
+            <a:avLst/>
+          </a:prstGeom>
+          <a:noFill/>
+          <a:ln/>
+        </p:spPr>
+        <p:txBody>
+          <a:bodyPr wrap="square" lIns="0" tIns="0" rIns="0" bIns="0" rtlCol="0" anchor="t"/>
+          <a:lstStyle/>
+          <a:p>
+            <a:pPr indent="0" marL="0">
+              <a:buNone/>
+            </a:pPr>
+            <a:r>
+              <a:rPr lang="en-US" sz="1100" dirty="0">
+                <a:solidFill>
+                  <a:srgbClr val="556B82"/>
+                </a:solidFill>
+                <a:latin typeface="Arial" pitchFamily="34" charset="0"/>
+                <a:ea typeface="Arial" pitchFamily="34" charset="-122"/>
+                <a:cs typeface="Arial" pitchFamily="34" charset="-120"/>
+              </a:rPr>
+              <a:t>/oauth/* proxies the login to Entra ID, Okta, Keycloak, SAP IAS, … Tokens are verified against the IdP's JWKS.</a:t>
+            </a:r>
+            <a:endParaRPr lang="en-US" sz="1100" dirty="0"/>
+          </a:p>
+        </p:txBody>
+      </p:sp>
+      <p:sp>
+        <p:nvSpPr>
+          <p:cNvPr id="12" name="Shape 10"/>
+          <p:cNvSpPr/>
+          <p:nvPr/>
+        </p:nvSpPr>
+        <p:spPr>
+          <a:xfrm>
+            <a:off x="548640" y="3831336"/>
+            <a:ext cx="5394960" cy="1097280"/>
+          </a:xfrm>
+          <a:prstGeom prst="roundRect">
+            <a:avLst>
+              <a:gd name="adj" fmla="val 6667"/>
+            </a:avLst>
+          </a:prstGeom>
+          <a:solidFill>
+            <a:srgbClr val="F5F6F7"/>
+          </a:solidFill>
+          <a:ln w="9525">
+            <a:solidFill>
+              <a:srgbClr val="E1E6EB"/>
+            </a:solidFill>
+            <a:prstDash val="solid"/>
+          </a:ln>
+        </p:spPr>
+      </p:sp>
+      <p:sp>
+        <p:nvSpPr>
+          <p:cNvPr id="13" name="Text 11"/>
+          <p:cNvSpPr/>
+          <p:nvPr/>
+        </p:nvSpPr>
+        <p:spPr>
+          <a:xfrm>
+            <a:off x="777240" y="4105656"/>
+            <a:ext cx="420624" cy="420624"/>
+          </a:xfrm>
+          <a:prstGeom prst="ellipse">
+            <a:avLst/>
+          </a:prstGeom>
+          <a:solidFill>
+            <a:srgbClr val="1D2D3E"/>
+          </a:solidFill>
+          <a:ln/>
+        </p:spPr>
+        <p:txBody>
+          <a:bodyPr wrap="square" lIns="0" tIns="0" rIns="0" bIns="0" rtlCol="0" anchor="ctr"/>
+          <a:lstStyle/>
+          <a:p>
+            <a:pPr algn="ctr" indent="0" marL="0">
+              <a:buNone/>
+            </a:pPr>
+            <a:r>
+              <a:rPr lang="en-US" sz="1500" b="1" dirty="0">
+                <a:solidFill>
+                  <a:srgbClr val="FFFFFF"/>
+                </a:solidFill>
+                <a:latin typeface="Arial" pitchFamily="34" charset="0"/>
+                <a:ea typeface="Arial" pitchFamily="34" charset="-122"/>
+                <a:cs typeface="Arial" pitchFamily="34" charset="-120"/>
+              </a:rPr>
+              <a:t>3</a:t>
+            </a:r>
+            <a:endParaRPr lang="en-US" sz="1500" dirty="0"/>
+          </a:p>
+        </p:txBody>
+      </p:sp>
+      <p:sp>
+        <p:nvSpPr>
+          <p:cNvPr id="14" name="Text 12"/>
+          <p:cNvSpPr txBox="1"/>
+          <p:nvPr/>
+        </p:nvSpPr>
+        <p:spPr>
+          <a:xfrm>
+            <a:off x="1417320" y="3995928"/>
+            <a:ext cx="4297680" cy="292608"/>
+          </a:xfrm>
+          <a:prstGeom prst="rect">
+            <a:avLst/>
+          </a:prstGeom>
+          <a:noFill/>
+          <a:ln/>
+        </p:spPr>
+        <p:txBody>
+          <a:bodyPr wrap="square" lIns="0" tIns="0" rIns="0" bIns="0" rtlCol="0" anchor="ctr"/>
+          <a:lstStyle/>
+          <a:p>
+            <a:pPr indent="0" marL="0">
+              <a:buNone/>
+            </a:pPr>
+            <a:r>
+              <a:rPr lang="en-US" sz="1400" b="1" dirty="0">
+                <a:solidFill>
+                  <a:srgbClr val="1D2D3E"/>
+                </a:solidFill>
+                <a:latin typeface="Arial" pitchFamily="34" charset="0"/>
+                <a:ea typeface="Arial" pitchFamily="34" charset="-122"/>
+                <a:cs typeface="Arial" pitchFamily="34" charset="-120"/>
+              </a:rPr>
+              <a:t>SAML bearer to SAP</a:t>
+            </a:r>
+            <a:endParaRPr lang="en-US" sz="1400" dirty="0"/>
+          </a:p>
+        </p:txBody>
+      </p:sp>
+      <p:sp>
+        <p:nvSpPr>
+          <p:cNvPr id="15" name="Text 13"/>
+          <p:cNvSpPr txBox="1"/>
+          <p:nvPr/>
+        </p:nvSpPr>
+        <p:spPr>
+          <a:xfrm>
+            <a:off x="1417320" y="4306824"/>
+            <a:ext cx="4297680" cy="640080"/>
+          </a:xfrm>
+          <a:prstGeom prst="rect">
+            <a:avLst/>
+          </a:prstGeom>
+          <a:noFill/>
+          <a:ln/>
+        </p:spPr>
+        <p:txBody>
+          <a:bodyPr wrap="square" lIns="0" tIns="0" rIns="0" bIns="0" rtlCol="0" anchor="t"/>
+          <a:lstStyle/>
+          <a:p>
+            <a:pPr indent="0" marL="0">
+              <a:buNone/>
+            </a:pPr>
+            <a:r>
+              <a:rPr lang="en-US" sz="1100" dirty="0">
+                <a:solidFill>
+                  <a:srgbClr val="556B82"/>
+                </a:solidFill>
+                <a:latin typeface="Arial" pitchFamily="34" charset="0"/>
+                <a:ea typeface="Arial" pitchFamily="34" charset="-122"/>
+                <a:cs typeface="Arial" pitchFamily="34" charset="-120"/>
+              </a:rPr>
+              <a:t>The proxy signs a SAML assertion for the user with the key from the secret store and exchanges it at SAP's OAuth server.</a:t>
+            </a:r>
+            <a:endParaRPr lang="en-US" sz="1100" dirty="0"/>
+          </a:p>
+        </p:txBody>
+      </p:sp>
+      <p:sp>
+        <p:nvSpPr>
+          <p:cNvPr id="16" name="Shape 14"/>
+          <p:cNvSpPr/>
+          <p:nvPr/>
+        </p:nvSpPr>
+        <p:spPr>
+          <a:xfrm>
+            <a:off x="6245352" y="1234440"/>
+            <a:ext cx="5394960" cy="1097280"/>
+          </a:xfrm>
+          <a:prstGeom prst="roundRect">
+            <a:avLst>
+              <a:gd name="adj" fmla="val 6667"/>
+            </a:avLst>
+          </a:prstGeom>
+          <a:solidFill>
+            <a:srgbClr val="F5F6F7"/>
+          </a:solidFill>
+          <a:ln w="9525">
+            <a:solidFill>
+              <a:srgbClr val="E1E6EB"/>
+            </a:solidFill>
+            <a:prstDash val="solid"/>
+          </a:ln>
+        </p:spPr>
+      </p:sp>
+      <p:sp>
+        <p:nvSpPr>
+          <p:cNvPr id="17" name="Text 15"/>
+          <p:cNvSpPr/>
+          <p:nvPr/>
+        </p:nvSpPr>
+        <p:spPr>
+          <a:xfrm>
+            <a:off x="6473952" y="1508760"/>
+            <a:ext cx="420624" cy="420624"/>
+          </a:xfrm>
+          <a:prstGeom prst="ellipse">
+            <a:avLst/>
+          </a:prstGeom>
+          <a:solidFill>
+            <a:srgbClr val="1D2D3E"/>
+          </a:solidFill>
+          <a:ln/>
+        </p:spPr>
+        <p:txBody>
+          <a:bodyPr wrap="square" lIns="0" tIns="0" rIns="0" bIns="0" rtlCol="0" anchor="ctr"/>
+          <a:lstStyle/>
+          <a:p>
+            <a:pPr algn="ctr" indent="0" marL="0">
+              <a:buNone/>
+            </a:pPr>
+            <a:r>
+              <a:rPr lang="en-US" sz="1500" b="1" dirty="0">
+                <a:solidFill>
+                  <a:srgbClr val="FFFFFF"/>
+                </a:solidFill>
+                <a:latin typeface="Arial" pitchFamily="34" charset="0"/>
+                <a:ea typeface="Arial" pitchFamily="34" charset="-122"/>
+                <a:cs typeface="Arial" pitchFamily="34" charset="-120"/>
+              </a:rPr>
+              <a:t>4</a:t>
+            </a:r>
+            <a:endParaRPr lang="en-US" sz="1500" dirty="0"/>
+          </a:p>
+        </p:txBody>
+      </p:sp>
+      <p:sp>
+        <p:nvSpPr>
+          <p:cNvPr id="18" name="Text 16"/>
+          <p:cNvSpPr txBox="1"/>
+          <p:nvPr/>
+        </p:nvSpPr>
+        <p:spPr>
+          <a:xfrm>
+            <a:off x="7114032" y="1399032"/>
+            <a:ext cx="4297680" cy="292608"/>
+          </a:xfrm>
+          <a:prstGeom prst="rect">
+            <a:avLst/>
+          </a:prstGeom>
+          <a:noFill/>
+          <a:ln/>
+        </p:spPr>
+        <p:txBody>
+          <a:bodyPr wrap="square" lIns="0" tIns="0" rIns="0" bIns="0" rtlCol="0" anchor="ctr"/>
+          <a:lstStyle/>
+          <a:p>
+            <a:pPr indent="0" marL="0">
+              <a:buNone/>
+            </a:pPr>
+            <a:r>
+              <a:rPr lang="en-US" sz="1400" b="1" dirty="0">
+                <a:solidFill>
+                  <a:srgbClr val="1D2D3E"/>
+                </a:solidFill>
+                <a:latin typeface="Arial" pitchFamily="34" charset="0"/>
+                <a:ea typeface="Arial" pitchFamily="34" charset="-122"/>
+                <a:cs typeface="Arial" pitchFamily="34" charset="-120"/>
+              </a:rPr>
+              <a:t>OData as the business user</a:t>
+            </a:r>
+            <a:endParaRPr lang="en-US" sz="1400" dirty="0"/>
+          </a:p>
+        </p:txBody>
+      </p:sp>
+      <p:sp>
+        <p:nvSpPr>
+          <p:cNvPr id="19" name="Text 17"/>
+          <p:cNvSpPr txBox="1"/>
+          <p:nvPr/>
+        </p:nvSpPr>
+        <p:spPr>
+          <a:xfrm>
+            <a:off x="7114032" y="1709928"/>
+            <a:ext cx="4297680" cy="640080"/>
+          </a:xfrm>
+          <a:prstGeom prst="rect">
+            <a:avLst/>
+          </a:prstGeom>
+          <a:noFill/>
+          <a:ln/>
+        </p:spPr>
+        <p:txBody>
+          <a:bodyPr wrap="square" lIns="0" tIns="0" rIns="0" bIns="0" rtlCol="0" anchor="t"/>
+          <a:lstStyle/>
+          <a:p>
+            <a:pPr indent="0" marL="0">
+              <a:buNone/>
+            </a:pPr>
+            <a:r>
+              <a:rPr lang="en-US" sz="1100" dirty="0">
+                <a:solidFill>
+                  <a:srgbClr val="556B82"/>
+                </a:solidFill>
+                <a:latin typeface="Arial" pitchFamily="34" charset="0"/>
+                <a:ea typeface="Arial" pitchFamily="34" charset="-122"/>
+                <a:cs typeface="Arial" pitchFamily="34" charset="-120"/>
+              </a:rPr>
+              <a:t>The S/4HANA call carries the user's own SAP token, so SAP authorizations apply per user. Tokens are cached per user.</a:t>
+            </a:r>
+            <a:endParaRPr lang="en-US" sz="1100" dirty="0"/>
+          </a:p>
+        </p:txBody>
+      </p:sp>
+      <p:sp>
+        <p:nvSpPr>
+          <p:cNvPr id="20" name="Shape 18"/>
+          <p:cNvSpPr/>
+          <p:nvPr/>
+        </p:nvSpPr>
+        <p:spPr>
+          <a:xfrm>
+            <a:off x="6245352" y="2532888"/>
+            <a:ext cx="5394960" cy="1097280"/>
+          </a:xfrm>
+          <a:prstGeom prst="roundRect">
+            <a:avLst>
+              <a:gd name="adj" fmla="val 6667"/>
+            </a:avLst>
+          </a:prstGeom>
+          <a:solidFill>
+            <a:srgbClr val="F5F6F7"/>
+          </a:solidFill>
+          <a:ln w="9525">
+            <a:solidFill>
+              <a:srgbClr val="E1E6EB"/>
+            </a:solidFill>
+            <a:prstDash val="solid"/>
+          </a:ln>
+        </p:spPr>
+      </p:sp>
+      <p:sp>
+        <p:nvSpPr>
+          <p:cNvPr id="21" name="Text 19"/>
+          <p:cNvSpPr/>
+          <p:nvPr/>
+        </p:nvSpPr>
+        <p:spPr>
+          <a:xfrm>
+            <a:off x="6473952" y="2807208"/>
+            <a:ext cx="420624" cy="420624"/>
+          </a:xfrm>
+          <a:prstGeom prst="ellipse">
+            <a:avLst/>
+          </a:prstGeom>
+          <a:solidFill>
+            <a:srgbClr val="1D2D3E"/>
+          </a:solidFill>
+          <a:ln/>
+        </p:spPr>
+        <p:txBody>
+          <a:bodyPr wrap="square" lIns="0" tIns="0" rIns="0" bIns="0" rtlCol="0" anchor="ctr"/>
+          <a:lstStyle/>
+          <a:p>
+            <a:pPr algn="ctr" indent="0" marL="0">
+              <a:buNone/>
+            </a:pPr>
+            <a:r>
+              <a:rPr lang="en-US" sz="1500" b="1" dirty="0">
+                <a:solidFill>
+                  <a:srgbClr val="FFFFFF"/>
+                </a:solidFill>
+                <a:latin typeface="Arial" pitchFamily="34" charset="0"/>
+                <a:ea typeface="Arial" pitchFamily="34" charset="-122"/>
+                <a:cs typeface="Arial" pitchFamily="34" charset="-120"/>
+              </a:rPr>
+              <a:t>5</a:t>
+            </a:r>
+            <a:endParaRPr lang="en-US" sz="1500" dirty="0"/>
+          </a:p>
+        </p:txBody>
+      </p:sp>
+      <p:sp>
+        <p:nvSpPr>
+          <p:cNvPr id="22" name="Text 20"/>
+          <p:cNvSpPr txBox="1"/>
+          <p:nvPr/>
+        </p:nvSpPr>
+        <p:spPr>
+          <a:xfrm>
+            <a:off x="7114032" y="2697480"/>
+            <a:ext cx="4297680" cy="292608"/>
+          </a:xfrm>
+          <a:prstGeom prst="rect">
+            <a:avLst/>
+          </a:prstGeom>
+          <a:noFill/>
+          <a:ln/>
+        </p:spPr>
+        <p:txBody>
+          <a:bodyPr wrap="square" lIns="0" tIns="0" rIns="0" bIns="0" rtlCol="0" anchor="ctr"/>
+          <a:lstStyle/>
+          <a:p>
+            <a:pPr indent="0" marL="0">
+              <a:buNone/>
+            </a:pPr>
+            <a:r>
+              <a:rPr lang="en-US" sz="1400" b="1" dirty="0">
+                <a:solidFill>
+                  <a:srgbClr val="1D2D3E"/>
+                </a:solidFill>
+                <a:latin typeface="Arial" pitchFamily="34" charset="0"/>
+                <a:ea typeface="Arial" pitchFamily="34" charset="-122"/>
+                <a:cs typeface="Arial" pitchFamily="34" charset="-120"/>
+              </a:rPr>
+              <a:t>More SAP systems</a:t>
+            </a:r>
+            <a:endParaRPr lang="en-US" sz="1400" dirty="0"/>
+          </a:p>
+        </p:txBody>
+      </p:sp>
+      <p:sp>
+        <p:nvSpPr>
+          <p:cNvPr id="23" name="Text 21"/>
+          <p:cNvSpPr txBox="1"/>
+          <p:nvPr/>
+        </p:nvSpPr>
+        <p:spPr>
+          <a:xfrm>
+            <a:off x="7114032" y="3008376"/>
+            <a:ext cx="4297680" cy="640080"/>
+          </a:xfrm>
+          <a:prstGeom prst="rect">
+            <a:avLst/>
+          </a:prstGeom>
+          <a:noFill/>
+          <a:ln/>
+        </p:spPr>
+        <p:txBody>
+          <a:bodyPr wrap="square" lIns="0" tIns="0" rIns="0" bIns="0" rtlCol="0" anchor="t"/>
+          <a:lstStyle/>
+          <a:p>
+            <a:pPr indent="0" marL="0">
+              <a:buNone/>
+            </a:pPr>
+            <a:r>
+              <a:rPr lang="en-US" sz="1100" dirty="0">
+                <a:solidFill>
+                  <a:srgbClr val="556B82"/>
+                </a:solidFill>
+                <a:latin typeface="Arial" pitchFamily="34" charset="0"/>
+                <a:ea typeface="Arial" pitchFamily="34" charset="-122"/>
+                <a:cs typeface="Arial" pitchFamily="34" charset="-120"/>
+              </a:rPr>
+              <a:t>Every ABAP system is a separate destination with its own trust set-up and AUTH_TYPE (per user or technical user).</a:t>
+            </a:r>
+            <a:endParaRPr lang="en-US" sz="1100" dirty="0"/>
+          </a:p>
+        </p:txBody>
+      </p:sp>
+      <p:sp>
+        <p:nvSpPr>
+          <p:cNvPr id="24" name="Shape 22"/>
+          <p:cNvSpPr/>
+          <p:nvPr/>
+        </p:nvSpPr>
+        <p:spPr>
+          <a:xfrm>
+            <a:off x="548640" y="5175504"/>
+            <a:ext cx="11091672" cy="502920"/>
+          </a:xfrm>
+          <a:prstGeom prst="roundRect">
+            <a:avLst>
+              <a:gd name="adj" fmla="val 14545"/>
+            </a:avLst>
+          </a:prstGeom>
+          <a:solidFill>
+            <a:srgbClr val="EBF8FF"/>
+          </a:solidFill>
+          <a:ln w="9525">
+            <a:solidFill>
+              <a:srgbClr val="0070F2"/>
+            </a:solidFill>
+            <a:prstDash val="solid"/>
+          </a:ln>
+        </p:spPr>
+      </p:sp>
+      <p:sp>
+        <p:nvSpPr>
+          <p:cNvPr id="25" name="Text 23"/>
+          <p:cNvSpPr txBox="1"/>
+          <p:nvPr/>
+        </p:nvSpPr>
+        <p:spPr>
+          <a:xfrm>
+            <a:off x="777240" y="5175504"/>
+            <a:ext cx="10634472" cy="502920"/>
+          </a:xfrm>
+          <a:prstGeom prst="rect">
+            <a:avLst/>
+          </a:prstGeom>
+          <a:noFill/>
+          <a:ln/>
+        </p:spPr>
+        <p:txBody>
+          <a:bodyPr wrap="square" lIns="0" tIns="0" rIns="0" bIns="0" rtlCol="0" anchor="ctr"/>
+          <a:lstStyle/>
+          <a:p>
+            <a:pPr indent="0" marL="0">
+              <a:buNone/>
+            </a:pPr>
+            <a:r>
+              <a:rPr lang="en-US" sz="1100" b="1" dirty="0">
+                <a:solidFill>
+                  <a:srgbClr val="0070F2"/>
+                </a:solidFill>
+                <a:latin typeface="Arial" pitchFamily="34" charset="0"/>
+                <a:ea typeface="Arial" pitchFamily="34" charset="-122"/>
+                <a:cs typeface="Arial" pitchFamily="34" charset="-120"/>
+              </a:rPr>
+              <a:t>No SAP BTP needed:  </a:t>
+            </a:r>
+            <a:pPr indent="0" marL="0">
+              <a:buNone/>
+            </a:pPr>
+            <a:r>
+              <a:rPr lang="en-US" sz="1100" dirty="0">
+                <a:solidFill>
+                  <a:srgbClr val="1D2D3E"/>
+                </a:solidFill>
+                <a:latin typeface="Arial" pitchFamily="34" charset="0"/>
+                <a:ea typeface="Arial" pitchFamily="34" charset="-122"/>
+                <a:cs typeface="Arial" pitchFamily="34" charset="-120"/>
+              </a:rPr>
+              <a:t>no Destination service, Connectivity, Cloud Connector or XSUAA. Just an OIDC IdP, a Node.js host and SAML2 trust in each SAP system.</a:t>
             </a:r>
             <a:endParaRPr lang="en-US" sz="1100" dirty="0"/>
           </a:p>

</xml_diff>